<commit_message>
Complete full-history CRSP project and PDF presentation
</commit_message>
<xml_diff>
--- a/Final/presentation/conservative_formula.pptx
+++ b/Final/presentation/conservative_formula.pptx
@@ -19,6 +19,7 @@
     <p:sldId id="267" r:id="rId19"/>
     <p:sldId id="268" r:id="rId20"/>
     <p:sldId id="269" r:id="rId21"/>
+    <p:sldId id="270" r:id="rId22"/>
   </p:sldIdLst>
   <p:sldSz cx="12191695" cy="6858000" type="screen4x3"/>
   <p:notesSz cx="6858000" cy="9144000"/>
@@ -585,7 +586,7 @@
           <a:lstStyle/>
           <a:p>
             <a:r>
-              <a:t>Signals are industry-neutralized, standardized and clipped at ±3; returns are industry-adjusted.</a:t>
+              <a:t>The evidence does not support the claim that the formula beats the market on recent data once known factors and realistic costs are taken into account.</a:t>
             </a:r>
           </a:p>
         </p:txBody>
@@ -655,7 +656,7 @@
           <a:lstStyle/>
           <a:p>
             <a:r>
-              <a:t>Labels matter: the long/short convention and the optimizer's alpha-scaling sensitivity were chosen after results were seen.</a:t>
+              <a:t>Signals are industry-neutralized, standardized and clipped at ±3; returns are industry-adjusted.</a:t>
             </a:r>
           </a:p>
         </p:txBody>
@@ -725,7 +726,7 @@
           <a:lstStyle/>
           <a:p>
             <a:r>
-              <a:t>The buffer recovers part of the cost drag but does not change the answer to the critical tests.</a:t>
+              <a:t>Labels matter: the long/short convention and the optimizer's alpha-scaling sensitivity were chosen after results were seen.</a:t>
             </a:r>
           </a:p>
         </p:txBody>
@@ -795,7 +796,7 @@
           <a:lstStyle/>
           <a:p>
             <a:r>
-              <a:t>These statements follow the accepted conclusions of the replication, attribution and critical tests.</a:t>
+              <a:t>The buffer recovers part of the cost drag but does not change the answer to the critical tests.</a:t>
             </a:r>
           </a:p>
         </p:txBody>
@@ -865,6 +866,76 @@
           <a:lstStyle/>
           <a:p>
             <a:r>
+              <a:t>These statements follow the accepted conclusions of the replication, attribution and critical tests.</a:t>
+            </a:r>
+          </a:p>
+        </p:txBody>
+      </p:sp>
+      <p:sp>
+        <p:nvSpPr>
+          <p:cNvPr id="4" name="Slide Number Placeholder 3"/>
+          <p:cNvSpPr>
+            <a:spLocks noGrp="1"/>
+          </p:cNvSpPr>
+          <p:nvPr>
+            <p:ph type="sldNum" idx="5" sz="quarter"/>
+          </p:nvPr>
+        </p:nvSpPr>
+        <p:spPr/>
+      </p:sp>
+    </p:spTree>
+  </p:cSld>
+  <p:clrMapOvr>
+    <a:masterClrMapping/>
+  </p:clrMapOvr>
+</p:notes>
+</file>
+
+<file path=ppt/notesSlides/notesSlide15.xml><?xml version="1.0" encoding="utf-8"?>
+<p:notes xmlns:a="http://schemas.openxmlformats.org/drawingml/2006/main" xmlns:p="http://schemas.openxmlformats.org/presentationml/2006/main" xmlns:r="http://schemas.openxmlformats.org/officeDocument/2006/relationships">
+  <p:cSld>
+    <p:spTree>
+      <p:nvGrpSpPr>
+        <p:cNvPr id="1" name=""/>
+        <p:cNvGrpSpPr/>
+        <p:nvPr/>
+      </p:nvGrpSpPr>
+      <p:grpSpPr>
+        <a:xfrm>
+          <a:off x="0" y="0"/>
+          <a:ext cx="0" cy="0"/>
+          <a:chOff x="0" y="0"/>
+          <a:chExt cx="0" cy="0"/>
+        </a:xfrm>
+      </p:grpSpPr>
+      <p:sp>
+        <p:nvSpPr>
+          <p:cNvPr id="2" name="Slide Image Placeholder 1"/>
+          <p:cNvSpPr>
+            <a:spLocks noGrp="1"/>
+          </p:cNvSpPr>
+          <p:nvPr>
+            <p:ph type="sldImg" idx="2"/>
+          </p:nvPr>
+        </p:nvSpPr>
+        <p:spPr/>
+      </p:sp>
+      <p:sp>
+        <p:nvSpPr>
+          <p:cNvPr id="3" name="Notes Placeholder 2"/>
+          <p:cNvSpPr>
+            <a:spLocks noGrp="1"/>
+          </p:cNvSpPr>
+          <p:nvPr>
+            <p:ph type="body" idx="3" sz="quarter"/>
+          </p:nvPr>
+        </p:nvSpPr>
+        <p:spPr/>
+        <p:txBody>
+          <a:bodyPr/>
+          <a:lstStyle/>
+          <a:p>
+            <a:r>
               <a:t>Every slide number is read from results/ through the loader, which refuses a file whose hash differs from the manifest. Security-level rows stay in the git-ignored output/ folder.</a:t>
             </a:r>
           </a:p>
@@ -1145,7 +1216,7 @@
           <a:lstStyle/>
           <a:p>
             <a:r>
-              <a:t>Gross of costs, paper definitions. Every gap above 1 pp has a documented explanation.</a:t>
+              <a:t>The 12-month dividend window is a disclosed convention: the paper specifies the share-count ratio but does not fully specify the dividend window. Price returns exclude distributions; total returns include them. Adjusting both prices and shares prevents a stock split from looking like a buyback.</a:t>
             </a:r>
           </a:p>
         </p:txBody>
@@ -1215,7 +1286,7 @@
           <a:lstStyle/>
           <a:p>
             <a:r>
-              <a:t>Paper t-values are compared with our OLS t; Newey–West t-statistics are reported alongside in the notebook.</a:t>
+              <a:t>Gross of costs, paper definitions. Candidate explanations and unresolved material gaps are listed in the notebook; no parameter was adjusted to force agreement with the paper.</a:t>
             </a:r>
           </a:p>
         </p:txBody>
@@ -1285,7 +1356,7 @@
           <a:lstStyle/>
           <a:p>
             <a:r>
-              <a:t>Break-even is the cost per dollar traded at which the net excess return or net Carhart alpha reaches zero.</a:t>
+              <a:t>Paper t-values are compared with our OLS t; Newey–West t-statistics are reported alongside in the notebook.</a:t>
             </a:r>
           </a:p>
         </p:txBody>
@@ -1355,7 +1426,7 @@
           <a:lstStyle/>
           <a:p>
             <a:r>
-              <a:t>No evidence of outperformance in 2017–2024, rather than proof of failure: the interval is wide.</a:t>
+              <a:t>Break-even is the cost per dollar traded at which the net excess return or net Carhart alpha reaches zero.</a:t>
             </a:r>
           </a:p>
         </p:txBody>
@@ -1425,7 +1496,7 @@
           <a:lstStyle/>
           <a:p>
             <a:r>
-              <a:t>The evidence does not support the claim that the formula beats the market on recent data once known factors and realistic costs are taken into account.</a:t>
+              <a:t>No evidence of outperformance in 2017–2024, rather than proof of failure: the interval is wide.</a:t>
             </a:r>
           </a:p>
         </p:txBody>
@@ -4461,7 +4532,7 @@
               </a:defRPr>
             </a:pPr>
             <a:r>
-              <a:t>The Conservative Formula: a critical replication on CRSP, 1929–2024</a:t>
+              <a:t>The Conservative Formula</a:t>
             </a:r>
           </a:p>
           <a:p>
@@ -4473,7 +4544,7 @@
               </a:defRPr>
             </a:pPr>
             <a:r>
-              <a:t>MTH 9897 Systematic Trading · Project 8 · [Add names and team number]</a:t>
+              <a:t>Yingni Chang · MTH 9897 Project 8 · CRSP replication, 1929–2024</a:t>
             </a:r>
           </a:p>
         </p:txBody>
@@ -4609,6 +4680,157 @@
               </a:defRPr>
             </a:pPr>
             <a:r>
+              <a:t>Headline 1990–2024: no significant net alpha</a:t>
+            </a:r>
+          </a:p>
+        </p:txBody>
+      </p:sp>
+      <p:sp>
+        <p:nvSpPr>
+          <p:cNvPr id="3" name="TextBox 2"/>
+          <p:cNvSpPr txBox="1"/>
+          <p:nvPr/>
+        </p:nvSpPr>
+        <p:spPr>
+          <a:xfrm>
+            <a:off x="457200" y="1280160"/>
+            <a:ext cx="11247120" cy="5212080"/>
+          </a:xfrm>
+          <a:prstGeom prst="rect">
+            <a:avLst/>
+          </a:prstGeom>
+          <a:noFill/>
+        </p:spPr>
+        <p:txBody>
+          <a:bodyPr wrap="square">
+            <a:spAutoFit/>
+          </a:bodyPr>
+          <a:lstStyle/>
+          <a:p>
+            <a:pPr>
+              <a:spcAft>
+                <a:spcPts val="600"/>
+              </a:spcAft>
+              <a:defRPr sz="1500">
+                <a:solidFill>
+                  <a:srgbClr val="1F2A33"/>
+                </a:solidFill>
+              </a:defRPr>
+            </a:pPr>
+            <a:r>
+              <a:t>Gross: excess over market 1.69% [−2.0%, 5.4%]; Carhart alpha 1.17% (t 1.05)</a:t>
+            </a:r>
+          </a:p>
+          <a:p>
+            <a:pPr>
+              <a:spcAft>
+                <a:spcPts val="600"/>
+              </a:spcAft>
+              <a:defRPr sz="1500">
+                <a:solidFill>
+                  <a:srgbClr val="1F2A33"/>
+                </a:solidFill>
+              </a:defRPr>
+            </a:pPr>
+            <a:r>
+              <a:t>Net of 30 bps: excess 0.73% [−3.0%, 4.4%]; alpha 0.20% [−2.0%, 2.4%]</a:t>
+            </a:r>
+          </a:p>
+          <a:p>
+            <a:pPr>
+              <a:spcAft>
+                <a:spcPts val="600"/>
+              </a:spcAft>
+              <a:defRPr sz="1500">
+                <a:solidFill>
+                  <a:srgbClr val="1F2A33"/>
+                </a:solidFill>
+              </a:defRPr>
+            </a:pPr>
+            <a:r>
+              <a:t>FF5 + momentum alpha, net of 30 bps: −2.00% (t −2.33)</a:t>
+            </a:r>
+          </a:p>
+          <a:p>
+            <a:pPr>
+              <a:spcAft>
+                <a:spcPts val="600"/>
+              </a:spcAft>
+              <a:defRPr sz="1500">
+                <a:solidFill>
+                  <a:srgbClr val="1F2A33"/>
+                </a:solidFill>
+              </a:defRPr>
+            </a:pPr>
+            <a:r>
+              <a:t>Still lower risk: 12.2% compounded with 13.5% volatility (market 10.1%, 15.2%)</a:t>
+            </a:r>
+          </a:p>
+          <a:p>
+            <a:pPr>
+              <a:spcAft>
+                <a:spcPts val="600"/>
+              </a:spcAft>
+              <a:defRPr sz="1500">
+                <a:solidFill>
+                  <a:srgbClr val="1F2A33"/>
+                </a:solidFill>
+              </a:defRPr>
+            </a:pPr>
+            <a:r>
+              <a:t>Cost-inclusive CMS alpha 3.72% (t 2.22)</a:t>
+            </a:r>
+          </a:p>
+        </p:txBody>
+      </p:sp>
+    </p:spTree>
+  </p:cSld>
+  <p:clrMapOvr>
+    <a:masterClrMapping/>
+  </p:clrMapOvr>
+</p:sld>
+</file>
+
+<file path=ppt/slides/slide11.xml><?xml version="1.0" encoding="utf-8"?>
+<p:sld xmlns:a="http://schemas.openxmlformats.org/drawingml/2006/main" xmlns:p="http://schemas.openxmlformats.org/presentationml/2006/main" xmlns:r="http://schemas.openxmlformats.org/officeDocument/2006/relationships">
+  <p:cSld>
+    <p:spTree>
+      <p:nvGrpSpPr>
+        <p:cNvPr id="1" name=""/>
+        <p:cNvGrpSpPr/>
+        <p:nvPr/>
+      </p:nvGrpSpPr>
+      <p:grpSpPr/>
+      <p:sp>
+        <p:nvSpPr>
+          <p:cNvPr id="2" name="TextBox 1"/>
+          <p:cNvSpPr txBox="1"/>
+          <p:nvPr/>
+        </p:nvSpPr>
+        <p:spPr>
+          <a:xfrm>
+            <a:off x="457200" y="274320"/>
+            <a:ext cx="11247120" cy="822960"/>
+          </a:xfrm>
+          <a:prstGeom prst="rect">
+            <a:avLst/>
+          </a:prstGeom>
+          <a:noFill/>
+        </p:spPr>
+        <p:txBody>
+          <a:bodyPr wrap="square">
+            <a:spAutoFit/>
+          </a:bodyPr>
+          <a:lstStyle/>
+          <a:p>
+            <a:pPr>
+              <a:defRPr sz="2800" b="1">
+                <a:solidFill>
+                  <a:srgbClr val="1F2A33"/>
+                </a:solidFill>
+              </a:defRPr>
+            </a:pPr>
+            <a:r>
               <a:t>Signal diagnostics</a:t>
             </a:r>
           </a:p>
@@ -4662,7 +4884,7 @@
               </a:defRPr>
             </a:pPr>
             <a:r>
-              <a:t>Decile spread D10−D1: 1.04% (1963–1989), 0.69% (1990–2016), 0.40% (2017–2024)</a:t>
+              <a:t>Decile spread D10−D1: 1.02% (1963–1989), 0.68% (1990–2016), 0.40% (2017–2024)</a:t>
             </a:r>
           </a:p>
           <a:p>
@@ -4677,7 +4899,7 @@
               </a:defRPr>
             </a:pPr>
             <a:r>
-              <a:t>Factor-mimicking paper portfolio: IR 0.51 at K = 1, 0.20 at K = 12</a:t>
+              <a:t>Factor-mimicking paper portfolio: IR 0.50 at K = 1, 0.20 at K = 12</a:t>
             </a:r>
           </a:p>
           <a:p>
@@ -4744,7 +4966,7 @@
 </p:sld>
 </file>
 
-<file path=ppt/slides/slide11.xml><?xml version="1.0" encoding="utf-8"?>
+<file path=ppt/slides/slide12.xml><?xml version="1.0" encoding="utf-8"?>
 <p:sld xmlns:a="http://schemas.openxmlformats.org/drawingml/2006/main" xmlns:p="http://schemas.openxmlformats.org/presentationml/2006/main" xmlns:r="http://schemas.openxmlformats.org/officeDocument/2006/relationships">
   <p:cSld>
     <p:spTree>
@@ -4822,7 +5044,7 @@
               </a:defRPr>
             </a:pPr>
             <a:r>
-              <a:t>Decile long/short, n = 3, 10 bps, borrow: 0.86% a year, IR 0.03, max drawdown −100.0%</a:t>
+              <a:t>Decile long/short, n = 3, 10 bps, borrow: 0.64% a year, IR 0.03, max drawdown −100.0%</a:t>
             </a:r>
           </a:p>
           <a:p>
@@ -4867,7 +5089,7 @@
               </a:defRPr>
             </a:pPr>
             <a:r>
-              <a:t>Linear optimizer, 1990–2024 net 30: Carhart alpha 1.42%–1.97% (2–5% bands, 20–40% turnover budget); three of the four 95% intervals exclude zero</a:t>
+              <a:t>Linear optimizer, 1990–2024 net 30: Carhart alpha 1.31%–1.95% (2–5% bands, 20–40% turnover budget); two of the four 95% intervals exclude zero</a:t>
             </a:r>
           </a:p>
           <a:p>
@@ -4882,7 +5104,7 @@
               </a:defRPr>
             </a:pPr>
             <a:r>
-              <a:t>Unadjusted intervals, selected from a 24-run grid; 2017–2024 alphas −2.70% to 0.06% (none of the twelve 95% intervals excludes zero); return-scaled alpha is a post-spec sensitivity</a:t>
+              <a:t>Unadjusted intervals, selected from a 24-run grid; 2017–2024 alphas −2.71% to 0.07% (none of the twelve 95% intervals excludes zero); return-scaled alpha is a post-spec sensitivity</a:t>
             </a:r>
           </a:p>
           <a:p>
@@ -4897,7 +5119,7 @@
               </a:defRPr>
             </a:pPr>
             <a:r>
-              <a:t>Quadratic optimization excluded: no commercial risk model</a:t>
+              <a:t>Further work: quadratic optimization with an estimated covariance model</a:t>
             </a:r>
           </a:p>
         </p:txBody>
@@ -4934,7 +5156,7 @@
 </p:sld>
 </file>
 
-<file path=ppt/slides/slide12.xml><?xml version="1.0" encoding="utf-8"?>
+<file path=ppt/slides/slide13.xml><?xml version="1.0" encoding="utf-8"?>
 <p:sld xmlns:a="http://schemas.openxmlformats.org/drawingml/2006/main" xmlns:p="http://schemas.openxmlformats.org/presentationml/2006/main" xmlns:r="http://schemas.openxmlformats.org/officeDocument/2006/relationships">
   <p:cSld>
     <p:spTree>
@@ -5124,7 +5346,7 @@
 </p:sld>
 </file>
 
-<file path=ppt/slides/slide13.xml><?xml version="1.0" encoding="utf-8"?>
+<file path=ppt/slides/slide14.xml><?xml version="1.0" encoding="utf-8"?>
 <p:sld xmlns:a="http://schemas.openxmlformats.org/drawingml/2006/main" xmlns:p="http://schemas.openxmlformats.org/presentationml/2006/main" xmlns:r="http://schemas.openxmlformats.org/officeDocument/2006/relationships">
   <p:cSld>
     <p:spTree>
@@ -5232,7 +5454,7 @@
               </a:defRPr>
             </a:pPr>
             <a:r>
-              <a:t>Alphas decay; 1990–2024 net of 30 bps: alpha 0.23% [−2.0%, 2.4%]</a:t>
+              <a:t>Alphas decay; 1990–2024 net of 30 bps: alpha 0.20% [−2.0%, 2.4%]</a:t>
             </a:r>
           </a:p>
           <a:p>
@@ -5290,7 +5512,7 @@
 </p:sld>
 </file>
 
-<file path=ppt/slides/slide14.xml><?xml version="1.0" encoding="utf-8"?>
+<file path=ppt/slides/slide15.xml><?xml version="1.0" encoding="utf-8"?>
 <p:sld xmlns:a="http://schemas.openxmlformats.org/drawingml/2006/main" xmlns:p="http://schemas.openxmlformats.org/presentationml/2006/main" xmlns:r="http://schemas.openxmlformats.org/officeDocument/2006/relationships">
   <p:cSld>
     <p:spTree>
@@ -5368,7 +5590,7 @@
               </a:defRPr>
             </a:pPr>
             <a:r>
-              <a:t>python -m crsp_pipeline extract --user &lt;wrds_username&gt;   (licensed data; not in the repository)</a:t>
+              <a:t>python -m crsp_pipeline.import_web   (full web exports; licensed data kept private)</a:t>
             </a:r>
           </a:p>
           <a:p>
@@ -5428,7 +5650,7 @@
               </a:defRPr>
             </a:pPr>
             <a:r>
-              <a:t>python presentation/build_deck.py</a:t>
+              <a:t>python presentation/build_pdf.py   (PDF slides and speaker notes)</a:t>
             </a:r>
           </a:p>
           <a:p>
@@ -5443,7 +5665,7 @@
               </a:defRPr>
             </a:pPr>
             <a:r>
-              <a:t>73 result files with sha256 hashes; data manifest 5eada288fe2c…</a:t>
+              <a:t>73 result files with sha256 hashes; data manifest 4816d582000a…</a:t>
             </a:r>
           </a:p>
         </p:txBody>
@@ -5685,7 +5907,7 @@
               </a:defRPr>
             </a:pPr>
             <a:r>
-              <a:t>CRSP monthly stock file via WRDS, extracted 2026-10-10; months 1925-12 to 2024-12</a:t>
+              <a:t>CRSP monthly stock file via WRDS, extracted 2026-10-13; months 1925-12 to 2024-12</a:t>
             </a:r>
           </a:p>
           <a:p>
@@ -5700,7 +5922,7 @@
               </a:defRPr>
             </a:pPr>
             <a:r>
-              <a:t>3,954,476 security-months, 26,746 securities, 22,869 delistings (110 imputed, 27 set to zero)</a:t>
+              <a:t>3,954,591 security-months, 26,746 securities, 22,869 delistings (2530 imputed, 317 set to zero)</a:t>
             </a:r>
           </a:p>
           <a:p>
@@ -6199,6 +6421,172 @@
               </a:defRPr>
             </a:pPr>
             <a:r>
+              <a:t>Signal construction and timing</a:t>
+            </a:r>
+          </a:p>
+        </p:txBody>
+      </p:sp>
+      <p:sp>
+        <p:nvSpPr>
+          <p:cNvPr id="3" name="TextBox 2"/>
+          <p:cNvSpPr txBox="1"/>
+          <p:nvPr/>
+        </p:nvSpPr>
+        <p:spPr>
+          <a:xfrm>
+            <a:off x="457200" y="1280160"/>
+            <a:ext cx="11247120" cy="5212080"/>
+          </a:xfrm>
+          <a:prstGeom prst="rect">
+            <a:avLst/>
+          </a:prstGeom>
+          <a:noFill/>
+        </p:spPr>
+        <p:txBody>
+          <a:bodyPr wrap="square">
+            <a:spAutoFit/>
+          </a:bodyPr>
+          <a:lstStyle/>
+          <a:p>
+            <a:pPr>
+              <a:spcAft>
+                <a:spcPts val="600"/>
+              </a:spcAft>
+              <a:defRPr sz="1500">
+                <a:solidFill>
+                  <a:srgbClr val="1F2A33"/>
+                </a:solidFill>
+              </a:defRPr>
+            </a:pPr>
+            <a:r>
+              <a:t>Volatility: annualized standard deviation of 36 consecutive monthly total returns</a:t>
+            </a:r>
+          </a:p>
+          <a:p>
+            <a:pPr>
+              <a:spcAft>
+                <a:spcPts val="600"/>
+              </a:spcAft>
+              <a:defRPr sz="1500">
+                <a:solidFill>
+                  <a:srgbClr val="1F2A33"/>
+                </a:solidFill>
+              </a:defRPr>
+            </a:pPr>
+            <a:r>
+              <a:t>Momentum: compound 11 monthly price returns, excluding the most recent month</a:t>
+            </a:r>
+          </a:p>
+          <a:p>
+            <a:pPr>
+              <a:spcAft>
+                <a:spcPts val="600"/>
+              </a:spcAft>
+              <a:defRPr sz="1500">
+                <a:solidFill>
+                  <a:srgbClr val="1F2A33"/>
+                </a:solidFill>
+              </a:defRPr>
+            </a:pPr>
+            <a:r>
+              <a:t>Dividend yield: trailing 12 months of split-adjusted dividends divided by the current adjusted price</a:t>
+            </a:r>
+          </a:p>
+          <a:p>
+            <a:pPr>
+              <a:spcAft>
+                <a:spcPts val="600"/>
+              </a:spcAft>
+              <a:defRPr sz="1500">
+                <a:solidFill>
+                  <a:srgbClr val="1F2A33"/>
+                </a:solidFill>
+              </a:defRPr>
+            </a:pPr>
+            <a:r>
+              <a:t>Net payout yield: dividend yield + 1 − latest adjusted shares / average adjusted shares over 24 months</a:t>
+            </a:r>
+          </a:p>
+          <a:p>
+            <a:pPr>
+              <a:spcAft>
+                <a:spcPts val="600"/>
+              </a:spcAft>
+              <a:defRPr sz="1500">
+                <a:solidFill>
+                  <a:srgbClr val="1F2A33"/>
+                </a:solidFill>
+              </a:defRPr>
+            </a:pPr>
+            <a:r>
+              <a:t>A falling share count raises payout yield; new share issuance lowers it</a:t>
+            </a:r>
+          </a:p>
+          <a:p>
+            <a:pPr>
+              <a:spcAft>
+                <a:spcPts val="600"/>
+              </a:spcAft>
+              <a:defRPr sz="1500">
+                <a:solidFill>
+                  <a:srgbClr val="1F2A33"/>
+                </a:solidFill>
+              </a:defRPr>
+            </a:pPr>
+            <a:r>
+              <a:t>Quarter-end information determines next month's holdings. No forward return enters selection.</a:t>
+            </a:r>
+          </a:p>
+        </p:txBody>
+      </p:sp>
+    </p:spTree>
+  </p:cSld>
+  <p:clrMapOvr>
+    <a:masterClrMapping/>
+  </p:clrMapOvr>
+</p:sld>
+</file>
+
+<file path=ppt/slides/slide6.xml><?xml version="1.0" encoding="utf-8"?>
+<p:sld xmlns:a="http://schemas.openxmlformats.org/drawingml/2006/main" xmlns:p="http://schemas.openxmlformats.org/presentationml/2006/main" xmlns:r="http://schemas.openxmlformats.org/officeDocument/2006/relationships">
+  <p:cSld>
+    <p:spTree>
+      <p:nvGrpSpPr>
+        <p:cNvPr id="1" name=""/>
+        <p:cNvGrpSpPr/>
+        <p:nvPr/>
+      </p:nvGrpSpPr>
+      <p:grpSpPr/>
+      <p:sp>
+        <p:nvSpPr>
+          <p:cNvPr id="2" name="TextBox 1"/>
+          <p:cNvSpPr txBox="1"/>
+          <p:nvPr/>
+        </p:nvSpPr>
+        <p:spPr>
+          <a:xfrm>
+            <a:off x="457200" y="274320"/>
+            <a:ext cx="11247120" cy="822960"/>
+          </a:xfrm>
+          <a:prstGeom prst="rect">
+            <a:avLst/>
+          </a:prstGeom>
+          <a:noFill/>
+        </p:spPr>
+        <p:txBody>
+          <a:bodyPr wrap="square">
+            <a:spAutoFit/>
+          </a:bodyPr>
+          <a:lstStyle/>
+          <a:p>
+            <a:pPr>
+              <a:defRPr sz="2800" b="1">
+                <a:solidFill>
+                  <a:srgbClr val="1F2A33"/>
+                </a:solidFill>
+              </a:defRPr>
+            </a:pPr>
+            <a:r>
               <a:t>Replication 1929–2016: close on return and risk</a:t>
             </a:r>
           </a:p>
@@ -6237,7 +6625,7 @@
               </a:defRPr>
             </a:pPr>
             <a:r>
-              <a:t>Conservative 14.85% compounded, 17.06% volatility (paper 15.1%, 16.5%)</a:t>
+              <a:t>Conservative 14.80% compounded, 17.06% volatility (paper 15.1%, 16.5%)</a:t>
             </a:r>
           </a:p>
           <a:p>
@@ -6267,7 +6655,7 @@
               </a:defRPr>
             </a:pPr>
             <a:r>
-              <a:t>Speculative 3.21% with 35.9% volatility</a:t>
+              <a:t>Speculative 3.24% with 35.9% volatility</a:t>
             </a:r>
           </a:p>
           <a:p>
@@ -6515,7 +6903,7 @@
                         <a:defRPr sz="1100" b="0"/>
                       </a:pPr>
                       <a:r>
-                        <a:t>12.0% / 12.9%</a:t>
+                        <a:t>12.0% / 13.0%</a:t>
                       </a:r>
                     </a:p>
                   </a:txBody>
@@ -6530,7 +6918,7 @@
                         <a:defRPr sz="1100" b="0"/>
                       </a:pPr>
                       <a:r>
-                        <a:t>15.9% / 15.6%</a:t>
+                        <a:t>15.9% / 15.5%</a:t>
                       </a:r>
                     </a:p>
                   </a:txBody>
@@ -6545,7 +6933,7 @@
                         <a:defRPr sz="1100" b="0"/>
                       </a:pPr>
                       <a:r>
-                        <a:t>10.2% / 10.5%</a:t>
+                        <a:t>10.2% / 10.4%</a:t>
                       </a:r>
                     </a:p>
                   </a:txBody>
@@ -6667,7 +7055,7 @@
                         <a:defRPr sz="1100" b="0"/>
                       </a:pPr>
                       <a:r>
-                        <a:t>20.1% / 21.2%</a:t>
+                        <a:t>20.1% / 21.1%</a:t>
                       </a:r>
                     </a:p>
                   </a:txBody>
@@ -6686,7 +7074,7 @@
 </p:sld>
 </file>
 
-<file path=ppt/slides/slide6.xml><?xml version="1.0" encoding="utf-8"?>
+<file path=ppt/slides/slide7.xml><?xml version="1.0" encoding="utf-8"?>
 <p:sld xmlns:a="http://schemas.openxmlformats.org/drawingml/2006/main" xmlns:p="http://schemas.openxmlformats.org/presentationml/2006/main" xmlns:r="http://schemas.openxmlformats.org/officeDocument/2006/relationships">
   <p:cSld>
     <p:spTree>
@@ -6764,7 +7152,7 @@
               </a:defRPr>
             </a:pPr>
             <a:r>
-              <a:t>CMS (Conservative − Speculative), 1963–2016: CAPM 14.24% vs 14.0%; FF5 8.70% vs 8.8%; FF5 + MOM 3.14% vs 3.3%</a:t>
+              <a:t>CMS (Conservative − Speculative), 1963–2016: CAPM 14.20% vs 14.0%; FF5 8.69% vs 8.8%; FF5 + MOM 3.12% vs 3.3%</a:t>
             </a:r>
           </a:p>
           <a:p>
@@ -6779,7 +7167,7 @@
               </a:defRPr>
             </a:pPr>
             <a:r>
-              <a:t>1929–2016: CAPM 12.41% vs 13.9%; Carhart 7.81% vs 8.8% (gap is pre-1963)</a:t>
+              <a:t>1929–2016: CAPM 12.33% vs 13.9%; Carhart 7.74% vs 8.8% (gap is pre-1963)</a:t>
             </a:r>
           </a:p>
           <a:p>
@@ -6794,7 +7182,7 @@
               </a:defRPr>
             </a:pPr>
             <a:r>
-              <a:t>Conservative long-only: Carhart alpha 3.28% (t 4.69)</a:t>
+              <a:t>Conservative long-only: Carhart alpha 3.23% (t 4.63)</a:t>
             </a:r>
           </a:p>
           <a:p>
@@ -6809,7 +7197,7 @@
               </a:defRPr>
             </a:pPr>
             <a:r>
-              <a:t>FF5 + momentum, 1963–2016: −0.04% (t −0.06) — profitability and investment explain it</a:t>
+              <a:t>FF5 + momentum, 1963–2016: −0.11% (t −0.14) — profitability and investment explain it</a:t>
             </a:r>
           </a:p>
           <a:p>
@@ -6824,7 +7212,7 @@
               </a:defRPr>
             </a:pPr>
             <a:r>
-              <a:t>CMS net of 30 bps, both legs paying: Carhart 5.86% (t 4.03)</a:t>
+              <a:t>CMS net of 30 bps, both legs paying: Carhart 5.78% (t 3.99)</a:t>
             </a:r>
           </a:p>
         </p:txBody>
@@ -6837,7 +7225,7 @@
 </p:sld>
 </file>
 
-<file path=ppt/slides/slide7.xml><?xml version="1.0" encoding="utf-8"?>
+<file path=ppt/slides/slide8.xml><?xml version="1.0" encoding="utf-8"?>
 <p:sld xmlns:a="http://schemas.openxmlformats.org/drawingml/2006/main" xmlns:p="http://schemas.openxmlformats.org/presentationml/2006/main" xmlns:r="http://schemas.openxmlformats.org/officeDocument/2006/relationships">
   <p:cSld>
     <p:spTree>
@@ -6930,7 +7318,7 @@
               </a:defRPr>
             </a:pPr>
             <a:r>
-              <a:t>Net of 30 bps, 1929–2016: 13.78% compounded</a:t>
+              <a:t>Net of 30 bps, 1929–2016: 13.73% compounded</a:t>
             </a:r>
           </a:p>
           <a:p>
@@ -6945,7 +7333,7 @@
               </a:defRPr>
             </a:pPr>
             <a:r>
-              <a:t>1990–2024 break-even: 53 bps (excess return), 37 bps (alpha)</a:t>
+              <a:t>1990–2024 break-even: 52 bps (excess return), 36 bps (alpha)</a:t>
             </a:r>
           </a:p>
           <a:p>
@@ -7090,7 +7478,7 @@
                         <a:defRPr sz="1100" b="0"/>
                       </a:pPr>
                       <a:r>
-                        <a:t>179</a:t>
+                        <a:t>178</a:t>
                       </a:r>
                     </a:p>
                   </a:txBody>
@@ -7122,7 +7510,7 @@
                         <a:defRPr sz="1100" b="0"/>
                       </a:pPr>
                       <a:r>
-                        <a:t>69</a:t>
+                        <a:t>66</a:t>
                       </a:r>
                     </a:p>
                   </a:txBody>
@@ -7137,7 +7525,7 @@
                         <a:defRPr sz="1100" b="0"/>
                       </a:pPr>
                       <a:r>
-                        <a:t>190</a:t>
+                        <a:t>187</a:t>
                       </a:r>
                     </a:p>
                   </a:txBody>
@@ -7169,7 +7557,7 @@
                         <a:defRPr sz="1100" b="0"/>
                       </a:pPr>
                       <a:r>
-                        <a:t>53</a:t>
+                        <a:t>52</a:t>
                       </a:r>
                     </a:p>
                   </a:txBody>
@@ -7184,7 +7572,7 @@
                         <a:defRPr sz="1100" b="0"/>
                       </a:pPr>
                       <a:r>
-                        <a:t>85</a:t>
+                        <a:t>84</a:t>
                       </a:r>
                     </a:p>
                   </a:txBody>
@@ -7216,7 +7604,7 @@
                         <a:defRPr sz="1100" b="0"/>
                       </a:pPr>
                       <a:r>
-                        <a:t>37</a:t>
+                        <a:t>36</a:t>
                       </a:r>
                     </a:p>
                   </a:txBody>
@@ -7231,7 +7619,7 @@
                         <a:defRPr sz="1100" b="0"/>
                       </a:pPr>
                       <a:r>
-                        <a:t>53</a:t>
+                        <a:t>52</a:t>
                       </a:r>
                     </a:p>
                   </a:txBody>
@@ -7297,7 +7685,7 @@
 </p:sld>
 </file>
 
-<file path=ppt/slides/slide8.xml><?xml version="1.0" encoding="utf-8"?>
+<file path=ppt/slides/slide9.xml><?xml version="1.0" encoding="utf-8"?>
 <p:sld xmlns:a="http://schemas.openxmlformats.org/drawingml/2006/main" xmlns:p="http://schemas.openxmlformats.org/presentationml/2006/main" xmlns:r="http://schemas.openxmlformats.org/officeDocument/2006/relationships">
   <p:cSld>
     <p:spTree>
@@ -7375,7 +7763,7 @@
               </a:defRPr>
             </a:pPr>
             <a:r>
-              <a:t>Carhart alpha (gross): 4.7% → 2.2% → 1.8% → −1.2%</a:t>
+              <a:t>Carhart alpha (gross): 4.7% → 2.1% → 1.7% → −1.2%</a:t>
             </a:r>
           </a:p>
           <a:p>
@@ -7591,7 +7979,7 @@
                         <a:defRPr sz="1100" b="0"/>
                       </a:pPr>
                       <a:r>
-                        <a:t>4.7% (5.05)</a:t>
+                        <a:t>4.7% (5.03)</a:t>
                       </a:r>
                     </a:p>
                   </a:txBody>
@@ -7606,7 +7994,7 @@
                         <a:defRPr sz="1100" b="0"/>
                       </a:pPr>
                       <a:r>
-                        <a:t>3.8% (4.16)</a:t>
+                        <a:t>3.8% (4.14)</a:t>
                       </a:r>
                     </a:p>
                   </a:txBody>
@@ -7653,7 +8041,7 @@
                         <a:defRPr sz="1100" b="0"/>
                       </a:pPr>
                       <a:r>
-                        <a:t>6.5%</a:t>
+                        <a:t>6.4%</a:t>
                       </a:r>
                     </a:p>
                   </a:txBody>
@@ -7668,7 +8056,7 @@
                         <a:defRPr sz="1100" b="0"/>
                       </a:pPr>
                       <a:r>
-                        <a:t>2.2% (3.01)</a:t>
+                        <a:t>2.1% (2.90)</a:t>
                       </a:r>
                     </a:p>
                   </a:txBody>
@@ -7683,7 +8071,7 @@
                         <a:defRPr sz="1100" b="0"/>
                       </a:pPr>
                       <a:r>
-                        <a:t>1.2% (1.68)</a:t>
+                        <a:t>1.2% (1.56)</a:t>
                       </a:r>
                     </a:p>
                   </a:txBody>
@@ -7745,7 +8133,7 @@
                         <a:defRPr sz="1100" b="0"/>
                       </a:pPr>
                       <a:r>
-                        <a:t>1.8% (1.37)</a:t>
+                        <a:t>1.7% (1.34)</a:t>
                       </a:r>
                     </a:p>
                   </a:txBody>
@@ -7760,7 +8148,7 @@
                         <a:defRPr sz="1100" b="0"/>
                       </a:pPr>
                       <a:r>
-                        <a:t>0.8% (0.59)</a:t>
+                        <a:t>0.7% (0.56)</a:t>
                       </a:r>
                     </a:p>
                   </a:txBody>
@@ -7822,7 +8210,7 @@
                         <a:defRPr sz="1100" b="0"/>
                       </a:pPr>
                       <a:r>
-                        <a:t>−1.2% (−0.62)</a:t>
+                        <a:t>−1.2% (−0.61)</a:t>
                       </a:r>
                     </a:p>
                   </a:txBody>
@@ -7899,7 +8287,7 @@
                         <a:defRPr sz="1100" b="0"/>
                       </a:pPr>
                       <a:r>
-                        <a:t>1.2% (1.07)</a:t>
+                        <a:t>1.2% (1.05)</a:t>
                       </a:r>
                     </a:p>
                   </a:txBody>
@@ -7914,7 +8302,7 @@
                         <a:defRPr sz="1100" b="0"/>
                       </a:pPr>
                       <a:r>
-                        <a:t>0.2% (0.21)</a:t>
+                        <a:t>0.2% (0.18)</a:t>
                       </a:r>
                     </a:p>
                   </a:txBody>
@@ -7925,157 +8313,6 @@
           </a:graphicData>
         </a:graphic>
       </p:graphicFrame>
-    </p:spTree>
-  </p:cSld>
-  <p:clrMapOvr>
-    <a:masterClrMapping/>
-  </p:clrMapOvr>
-</p:sld>
-</file>
-
-<file path=ppt/slides/slide9.xml><?xml version="1.0" encoding="utf-8"?>
-<p:sld xmlns:a="http://schemas.openxmlformats.org/drawingml/2006/main" xmlns:p="http://schemas.openxmlformats.org/presentationml/2006/main" xmlns:r="http://schemas.openxmlformats.org/officeDocument/2006/relationships">
-  <p:cSld>
-    <p:spTree>
-      <p:nvGrpSpPr>
-        <p:cNvPr id="1" name=""/>
-        <p:cNvGrpSpPr/>
-        <p:nvPr/>
-      </p:nvGrpSpPr>
-      <p:grpSpPr/>
-      <p:sp>
-        <p:nvSpPr>
-          <p:cNvPr id="2" name="TextBox 1"/>
-          <p:cNvSpPr txBox="1"/>
-          <p:nvPr/>
-        </p:nvSpPr>
-        <p:spPr>
-          <a:xfrm>
-            <a:off x="457200" y="274320"/>
-            <a:ext cx="11247120" cy="822960"/>
-          </a:xfrm>
-          <a:prstGeom prst="rect">
-            <a:avLst/>
-          </a:prstGeom>
-          <a:noFill/>
-        </p:spPr>
-        <p:txBody>
-          <a:bodyPr wrap="square">
-            <a:spAutoFit/>
-          </a:bodyPr>
-          <a:lstStyle/>
-          <a:p>
-            <a:pPr>
-              <a:defRPr sz="2800" b="1">
-                <a:solidFill>
-                  <a:srgbClr val="1F2A33"/>
-                </a:solidFill>
-              </a:defRPr>
-            </a:pPr>
-            <a:r>
-              <a:t>Headline 1990–2024: no significant net alpha</a:t>
-            </a:r>
-          </a:p>
-        </p:txBody>
-      </p:sp>
-      <p:sp>
-        <p:nvSpPr>
-          <p:cNvPr id="3" name="TextBox 2"/>
-          <p:cNvSpPr txBox="1"/>
-          <p:nvPr/>
-        </p:nvSpPr>
-        <p:spPr>
-          <a:xfrm>
-            <a:off x="457200" y="1280160"/>
-            <a:ext cx="11247120" cy="5212080"/>
-          </a:xfrm>
-          <a:prstGeom prst="rect">
-            <a:avLst/>
-          </a:prstGeom>
-          <a:noFill/>
-        </p:spPr>
-        <p:txBody>
-          <a:bodyPr wrap="square">
-            <a:spAutoFit/>
-          </a:bodyPr>
-          <a:lstStyle/>
-          <a:p>
-            <a:pPr>
-              <a:spcAft>
-                <a:spcPts val="600"/>
-              </a:spcAft>
-              <a:defRPr sz="1500">
-                <a:solidFill>
-                  <a:srgbClr val="1F2A33"/>
-                </a:solidFill>
-              </a:defRPr>
-            </a:pPr>
-            <a:r>
-              <a:t>Gross: excess over market 1.72% [−2.0%, 5.4%]; Carhart alpha 1.20% (t 1.07)</a:t>
-            </a:r>
-          </a:p>
-          <a:p>
-            <a:pPr>
-              <a:spcAft>
-                <a:spcPts val="600"/>
-              </a:spcAft>
-              <a:defRPr sz="1500">
-                <a:solidFill>
-                  <a:srgbClr val="1F2A33"/>
-                </a:solidFill>
-              </a:defRPr>
-            </a:pPr>
-            <a:r>
-              <a:t>Net of 30 bps: excess 0.76% [−2.9%, 4.5%]; alpha 0.23% [−2.0%, 2.4%]</a:t>
-            </a:r>
-          </a:p>
-          <a:p>
-            <a:pPr>
-              <a:spcAft>
-                <a:spcPts val="600"/>
-              </a:spcAft>
-              <a:defRPr sz="1500">
-                <a:solidFill>
-                  <a:srgbClr val="1F2A33"/>
-                </a:solidFill>
-              </a:defRPr>
-            </a:pPr>
-            <a:r>
-              <a:t>FF5 + momentum alpha, net of 30 bps: −1.97% (t −2.30)</a:t>
-            </a:r>
-          </a:p>
-          <a:p>
-            <a:pPr>
-              <a:spcAft>
-                <a:spcPts val="600"/>
-              </a:spcAft>
-              <a:defRPr sz="1500">
-                <a:solidFill>
-                  <a:srgbClr val="1F2A33"/>
-                </a:solidFill>
-              </a:defRPr>
-            </a:pPr>
-            <a:r>
-              <a:t>Still lower risk: 12.3% compounded with 13.5% volatility (market 10.1%, 15.2%)</a:t>
-            </a:r>
-          </a:p>
-          <a:p>
-            <a:pPr>
-              <a:spcAft>
-                <a:spcPts val="600"/>
-              </a:spcAft>
-              <a:defRPr sz="1500">
-                <a:solidFill>
-                  <a:srgbClr val="1F2A33"/>
-                </a:solidFill>
-              </a:defRPr>
-            </a:pPr>
-            <a:r>
-              <a:t>Cost-inclusive CMS alpha 3.77% (t 2.23)</a:t>
-            </a:r>
-          </a:p>
-        </p:txBody>
-      </p:sp>
     </p:spTree>
   </p:cSld>
   <p:clrMapOvr>

</xml_diff>

<commit_message>
Complete three-pass review with payout, sector and quadratic checks
</commit_message>
<xml_diff>
--- a/Final/presentation/conservative_formula.pptx
+++ b/Final/presentation/conservative_formula.pptx
@@ -20,6 +20,9 @@
     <p:sldId id="268" r:id="rId20"/>
     <p:sldId id="269" r:id="rId21"/>
     <p:sldId id="270" r:id="rId22"/>
+    <p:sldId id="271" r:id="rId23"/>
+    <p:sldId id="272" r:id="rId24"/>
+    <p:sldId id="273" r:id="rId25"/>
   </p:sldIdLst>
   <p:sldSz cx="12191695" cy="6858000" type="screen4x3"/>
   <p:notesSz cx="6858000" cy="9144000"/>
@@ -656,7 +659,7 @@
           <a:lstStyle/>
           <a:p>
             <a:r>
-              <a:t>Signals are industry-neutralized, standardized and clipped at ±3; returns are industry-adjusted.</a:t>
+              <a:t>This directly addresses the professor's payout warning. The latest/24-month-average share ratio comes from paper page 4; the 12-month dividend window is a disclosed convention. The review adds synthetic tests for repurchases, issuance and split neutrality, plus 1,200 independent signal calculations.</a:t>
             </a:r>
           </a:p>
         </p:txBody>
@@ -726,7 +729,7 @@
           <a:lstStyle/>
           <a:p>
             <a:r>
-              <a:t>Labels matter: the long/short convention and the optimizer's alpha-scaling sensitivity were chosen after results were seen.</a:t>
+              <a:t>Exact monthly allocation plus selection plus the universe-to-market bridge reconciles to baseline excess returns. Selection includes interaction. The quota rule follows the professor's Enhanced Momentum example, using counts rather than cap weights, largest-remainder rounding and equal stock weights.</a:t>
             </a:r>
           </a:p>
         </p:txBody>
@@ -796,7 +799,7 @@
           <a:lstStyle/>
           <a:p>
             <a:r>
-              <a:t>The buffer recovers part of the cost drag but does not change the answer to the critical tests.</a:t>
+              <a:t>Signals are industry-neutralized, standardized and clipped at ±3; returns are industry-adjusted.</a:t>
             </a:r>
           </a:p>
         </p:txBody>
@@ -866,7 +869,7 @@
           <a:lstStyle/>
           <a:p>
             <a:r>
-              <a:t>These statements follow the accepted conclusions of the replication, attribution and critical tests.</a:t>
+              <a:t>Labels matter: the long/short convention and the optimizer's alpha-scaling sensitivity were chosen after results were seen.</a:t>
             </a:r>
           </a:p>
         </p:txBody>
@@ -892,6 +895,216 @@
 </file>
 
 <file path=ppt/notesSlides/notesSlide15.xml><?xml version="1.0" encoding="utf-8"?>
+<p:notes xmlns:a="http://schemas.openxmlformats.org/drawingml/2006/main" xmlns:p="http://schemas.openxmlformats.org/presentationml/2006/main" xmlns:r="http://schemas.openxmlformats.org/officeDocument/2006/relationships">
+  <p:cSld>
+    <p:spTree>
+      <p:nvGrpSpPr>
+        <p:cNvPr id="1" name=""/>
+        <p:cNvGrpSpPr/>
+        <p:nvPr/>
+      </p:nvGrpSpPr>
+      <p:grpSpPr>
+        <a:xfrm>
+          <a:off x="0" y="0"/>
+          <a:ext cx="0" cy="0"/>
+          <a:chOff x="0" y="0"/>
+          <a:chExt cx="0" cy="0"/>
+        </a:xfrm>
+      </p:grpSpPr>
+      <p:sp>
+        <p:nvSpPr>
+          <p:cNvPr id="2" name="Slide Image Placeholder 1"/>
+          <p:cNvSpPr>
+            <a:spLocks noGrp="1"/>
+          </p:cNvSpPr>
+          <p:nvPr>
+            <p:ph type="sldImg" idx="2"/>
+          </p:nvPr>
+        </p:nvSpPr>
+        <p:spPr/>
+      </p:sp>
+      <p:sp>
+        <p:nvSpPr>
+          <p:cNvPr id="3" name="Notes Placeholder 2"/>
+          <p:cNvSpPr>
+            <a:spLocks noGrp="1"/>
+          </p:cNvSpPr>
+          <p:nvPr>
+            <p:ph type="body" idx="3" sz="quarter"/>
+          </p:nvPr>
+        </p:nvSpPr>
+        <p:spPr/>
+        <p:txBody>
+          <a:bodyPr/>
+          <a:lstStyle/>
+          <a:p>
+            <a:r>
+              <a:t>This fulfills the quadratic optimization requirement using an estimated risk model. A positive semidefinite 50% diagonal shrinkage estimate regularizes 1,000 stocks with 36 observations. Covariance is scaled to three months assuming no autocorrelation. Both gamma values and all feasibility relaxations are reported in the notebook. These are long-only portfolios with substantial market exposure.</a:t>
+            </a:r>
+          </a:p>
+        </p:txBody>
+      </p:sp>
+      <p:sp>
+        <p:nvSpPr>
+          <p:cNvPr id="4" name="Slide Number Placeholder 3"/>
+          <p:cNvSpPr>
+            <a:spLocks noGrp="1"/>
+          </p:cNvSpPr>
+          <p:nvPr>
+            <p:ph type="sldNum" idx="5" sz="quarter"/>
+          </p:nvPr>
+        </p:nvSpPr>
+        <p:spPr/>
+      </p:sp>
+    </p:spTree>
+  </p:cSld>
+  <p:clrMapOvr>
+    <a:masterClrMapping/>
+  </p:clrMapOvr>
+</p:notes>
+</file>
+
+<file path=ppt/notesSlides/notesSlide16.xml><?xml version="1.0" encoding="utf-8"?>
+<p:notes xmlns:a="http://schemas.openxmlformats.org/drawingml/2006/main" xmlns:p="http://schemas.openxmlformats.org/presentationml/2006/main" xmlns:r="http://schemas.openxmlformats.org/officeDocument/2006/relationships">
+  <p:cSld>
+    <p:spTree>
+      <p:nvGrpSpPr>
+        <p:cNvPr id="1" name=""/>
+        <p:cNvGrpSpPr/>
+        <p:nvPr/>
+      </p:nvGrpSpPr>
+      <p:grpSpPr>
+        <a:xfrm>
+          <a:off x="0" y="0"/>
+          <a:ext cx="0" cy="0"/>
+          <a:chOff x="0" y="0"/>
+          <a:chExt cx="0" cy="0"/>
+        </a:xfrm>
+      </p:grpSpPr>
+      <p:sp>
+        <p:nvSpPr>
+          <p:cNvPr id="2" name="Slide Image Placeholder 1"/>
+          <p:cNvSpPr>
+            <a:spLocks noGrp="1"/>
+          </p:cNvSpPr>
+          <p:nvPr>
+            <p:ph type="sldImg" idx="2"/>
+          </p:nvPr>
+        </p:nvSpPr>
+        <p:spPr/>
+      </p:sp>
+      <p:sp>
+        <p:nvSpPr>
+          <p:cNvPr id="3" name="Notes Placeholder 2"/>
+          <p:cNvSpPr>
+            <a:spLocks noGrp="1"/>
+          </p:cNvSpPr>
+          <p:nvPr>
+            <p:ph type="body" idx="3" sz="quarter"/>
+          </p:nvPr>
+        </p:nvSpPr>
+        <p:spPr/>
+        <p:txBody>
+          <a:bodyPr/>
+          <a:lstStyle/>
+          <a:p>
+            <a:r>
+              <a:t>The buffer recovers part of the cost drag but does not change the answer to the critical tests.</a:t>
+            </a:r>
+          </a:p>
+        </p:txBody>
+      </p:sp>
+      <p:sp>
+        <p:nvSpPr>
+          <p:cNvPr id="4" name="Slide Number Placeholder 3"/>
+          <p:cNvSpPr>
+            <a:spLocks noGrp="1"/>
+          </p:cNvSpPr>
+          <p:nvPr>
+            <p:ph type="sldNum" idx="5" sz="quarter"/>
+          </p:nvPr>
+        </p:nvSpPr>
+        <p:spPr/>
+      </p:sp>
+    </p:spTree>
+  </p:cSld>
+  <p:clrMapOvr>
+    <a:masterClrMapping/>
+  </p:clrMapOvr>
+</p:notes>
+</file>
+
+<file path=ppt/notesSlides/notesSlide17.xml><?xml version="1.0" encoding="utf-8"?>
+<p:notes xmlns:a="http://schemas.openxmlformats.org/drawingml/2006/main" xmlns:p="http://schemas.openxmlformats.org/presentationml/2006/main" xmlns:r="http://schemas.openxmlformats.org/officeDocument/2006/relationships">
+  <p:cSld>
+    <p:spTree>
+      <p:nvGrpSpPr>
+        <p:cNvPr id="1" name=""/>
+        <p:cNvGrpSpPr/>
+        <p:nvPr/>
+      </p:nvGrpSpPr>
+      <p:grpSpPr>
+        <a:xfrm>
+          <a:off x="0" y="0"/>
+          <a:ext cx="0" cy="0"/>
+          <a:chOff x="0" y="0"/>
+          <a:chExt cx="0" cy="0"/>
+        </a:xfrm>
+      </p:grpSpPr>
+      <p:sp>
+        <p:nvSpPr>
+          <p:cNvPr id="2" name="Slide Image Placeholder 1"/>
+          <p:cNvSpPr>
+            <a:spLocks noGrp="1"/>
+          </p:cNvSpPr>
+          <p:nvPr>
+            <p:ph type="sldImg" idx="2"/>
+          </p:nvPr>
+        </p:nvSpPr>
+        <p:spPr/>
+      </p:sp>
+      <p:sp>
+        <p:nvSpPr>
+          <p:cNvPr id="3" name="Notes Placeholder 2"/>
+          <p:cNvSpPr>
+            <a:spLocks noGrp="1"/>
+          </p:cNvSpPr>
+          <p:nvPr>
+            <p:ph type="body" idx="3" sz="quarter"/>
+          </p:nvPr>
+        </p:nvSpPr>
+        <p:spPr/>
+        <p:txBody>
+          <a:bodyPr/>
+          <a:lstStyle/>
+          <a:p>
+            <a:r>
+              <a:t>These statements follow the accepted conclusions of the replication, attribution and critical tests.</a:t>
+            </a:r>
+          </a:p>
+        </p:txBody>
+      </p:sp>
+      <p:sp>
+        <p:nvSpPr>
+          <p:cNvPr id="4" name="Slide Number Placeholder 3"/>
+          <p:cNvSpPr>
+            <a:spLocks noGrp="1"/>
+          </p:cNvSpPr>
+          <p:nvPr>
+            <p:ph type="sldNum" idx="5" sz="quarter"/>
+          </p:nvPr>
+        </p:nvSpPr>
+        <p:spPr/>
+      </p:sp>
+    </p:spTree>
+  </p:cSld>
+  <p:clrMapOvr>
+    <a:masterClrMapping/>
+  </p:clrMapOvr>
+</p:notes>
+</file>
+
+<file path=ppt/notesSlides/notesSlide18.xml><?xml version="1.0" encoding="utf-8"?>
 <p:notes xmlns:a="http://schemas.openxmlformats.org/drawingml/2006/main" xmlns:p="http://schemas.openxmlformats.org/presentationml/2006/main" xmlns:r="http://schemas.openxmlformats.org/officeDocument/2006/relationships">
   <p:cSld>
     <p:spTree>
@@ -4831,6 +5044,338 @@
               </a:defRPr>
             </a:pPr>
             <a:r>
+              <a:t>Net payout: dividends and share repurchases</a:t>
+            </a:r>
+          </a:p>
+        </p:txBody>
+      </p:sp>
+      <p:sp>
+        <p:nvSpPr>
+          <p:cNvPr id="3" name="TextBox 2"/>
+          <p:cNvSpPr txBox="1"/>
+          <p:nvPr/>
+        </p:nvSpPr>
+        <p:spPr>
+          <a:xfrm>
+            <a:off x="457200" y="1280160"/>
+            <a:ext cx="11247120" cy="5212080"/>
+          </a:xfrm>
+          <a:prstGeom prst="rect">
+            <a:avLst/>
+          </a:prstGeom>
+          <a:noFill/>
+        </p:spPr>
+        <p:txBody>
+          <a:bodyPr wrap="square">
+            <a:spAutoFit/>
+          </a:bodyPr>
+          <a:lstStyle/>
+          <a:p>
+            <a:pPr>
+              <a:spcAft>
+                <a:spcPts val="600"/>
+              </a:spcAft>
+              <a:defRPr sz="1500">
+                <a:solidFill>
+                  <a:srgbClr val="1F2A33"/>
+                </a:solidFill>
+              </a:defRPr>
+            </a:pPr>
+            <a:r>
+              <a:t>NPY = trailing dividend yield + 1 − latest adjusted shares / 24-month average adjusted shares</a:t>
+            </a:r>
+          </a:p>
+          <a:p>
+            <a:pPr>
+              <a:spcAft>
+                <a:spcPts val="600"/>
+              </a:spcAft>
+              <a:defRPr sz="1500">
+                <a:solidFill>
+                  <a:srgbClr val="1F2A33"/>
+                </a:solidFill>
+              </a:defRPr>
+            </a:pPr>
+            <a:r>
+              <a:t>Repurchases raise NPY; share issuance lowers it. Splits must leave the adjusted share count unchanged</a:t>
+            </a:r>
+          </a:p>
+          <a:p>
+            <a:pPr>
+              <a:spcAft>
+                <a:spcPts val="600"/>
+              </a:spcAft>
+              <a:defRPr sz="1500">
+                <a:solidFill>
+                  <a:srgbClr val="1F2A33"/>
+                </a:solidFill>
+              </a:defRPr>
+            </a:pPr>
+            <a:r>
+              <a:t>1929–2016 gross CAGR: 14.80% using NPY versus 13.44% using dividends alone</a:t>
+            </a:r>
+          </a:p>
+          <a:p>
+            <a:pPr>
+              <a:spcAft>
+                <a:spcPts val="600"/>
+              </a:spcAft>
+              <a:defRPr sz="1500">
+                <a:solidFill>
+                  <a:srgbClr val="1F2A33"/>
+                </a:solidFill>
+              </a:defRPr>
+            </a:pPr>
+            <a:r>
+              <a:t>Paired net-30 arithmetic gain from NPY: 1.22% per year [0.56%, 1.87%]</a:t>
+            </a:r>
+          </a:p>
+          <a:p>
+            <a:pPr>
+              <a:spcAft>
+                <a:spcPts val="600"/>
+              </a:spcAft>
+              <a:defRPr sz="1500">
+                <a:solidFill>
+                  <a:srgbClr val="1F2A33"/>
+                </a:solidFill>
+              </a:defRPr>
+            </a:pPr>
+            <a:r>
+              <a:t>Same universe, low-volatility pool, momentum signal, weights, quarterly dates, and costs in the comparison</a:t>
+            </a:r>
+          </a:p>
+          <a:p>
+            <a:pPr>
+              <a:spcAft>
+                <a:spcPts val="600"/>
+              </a:spcAft>
+              <a:defRPr sz="1500">
+                <a:solidFill>
+                  <a:srgbClr val="1F2A33"/>
+                </a:solidFill>
+              </a:defRPr>
+            </a:pPr>
+            <a:r>
+              <a:t>Share-count change measures net repurchases after issuance; it is not reported buyback cash flow</a:t>
+            </a:r>
+          </a:p>
+        </p:txBody>
+      </p:sp>
+    </p:spTree>
+  </p:cSld>
+  <p:clrMapOvr>
+    <a:masterClrMapping/>
+  </p:clrMapOvr>
+</p:sld>
+</file>
+
+<file path=ppt/slides/slide12.xml><?xml version="1.0" encoding="utf-8"?>
+<p:sld xmlns:a="http://schemas.openxmlformats.org/drawingml/2006/main" xmlns:p="http://schemas.openxmlformats.org/presentationml/2006/main" xmlns:r="http://schemas.openxmlformats.org/officeDocument/2006/relationships">
+  <p:cSld>
+    <p:spTree>
+      <p:nvGrpSpPr>
+        <p:cNvPr id="1" name=""/>
+        <p:cNvGrpSpPr/>
+        <p:nvPr/>
+      </p:nvGrpSpPr>
+      <p:grpSpPr/>
+      <p:sp>
+        <p:nvSpPr>
+          <p:cNvPr id="2" name="TextBox 1"/>
+          <p:cNvSpPr txBox="1"/>
+          <p:nvPr/>
+        </p:nvSpPr>
+        <p:spPr>
+          <a:xfrm>
+            <a:off x="457200" y="274320"/>
+            <a:ext cx="11247120" cy="822960"/>
+          </a:xfrm>
+          <a:prstGeom prst="rect">
+            <a:avLst/>
+          </a:prstGeom>
+          <a:noFill/>
+        </p:spPr>
+        <p:txBody>
+          <a:bodyPr wrap="square">
+            <a:spAutoFit/>
+          </a:bodyPr>
+          <a:lstStyle/>
+          <a:p>
+            <a:pPr>
+              <a:defRPr sz="2800" b="1">
+                <a:solidFill>
+                  <a:srgbClr val="1F2A33"/>
+                </a:solidFill>
+              </a:defRPr>
+            </a:pPr>
+            <a:r>
+              <a:t>Sector positioning: allocation versus selection</a:t>
+            </a:r>
+          </a:p>
+        </p:txBody>
+      </p:sp>
+      <p:sp>
+        <p:nvSpPr>
+          <p:cNvPr id="3" name="TextBox 2"/>
+          <p:cNvSpPr txBox="1"/>
+          <p:nvPr/>
+        </p:nvSpPr>
+        <p:spPr>
+          <a:xfrm>
+            <a:off x="457200" y="1280160"/>
+            <a:ext cx="11247120" cy="5212080"/>
+          </a:xfrm>
+          <a:prstGeom prst="rect">
+            <a:avLst/>
+          </a:prstGeom>
+          <a:noFill/>
+        </p:spPr>
+        <p:txBody>
+          <a:bodyPr wrap="square">
+            <a:spAutoFit/>
+          </a:bodyPr>
+          <a:lstStyle/>
+          <a:p>
+            <a:pPr>
+              <a:spcAft>
+                <a:spcPts val="600"/>
+              </a:spcAft>
+              <a:defRPr sz="1500">
+                <a:solidFill>
+                  <a:srgbClr val="1F2A33"/>
+                </a:solidFill>
+              </a:defRPr>
+            </a:pPr>
+            <a:r>
+              <a:t>Paper scores are compared across sectors (page 4); the professor's sector-aware variant is reported separately</a:t>
+            </a:r>
+          </a:p>
+          <a:p>
+            <a:pPr>
+              <a:spcAft>
+                <a:spcPts val="600"/>
+              </a:spcAft>
+              <a:defRPr sz="1500">
+                <a:solidFill>
+                  <a:srgbClr val="1F2A33"/>
+                </a:solidFill>
+              </a:defRPr>
+            </a:pPr>
+            <a:r>
+              <a:t>1929–2016 gross arithmetic excess return: 4.80% per year</a:t>
+            </a:r>
+          </a:p>
+          <a:p>
+            <a:pPr lvl="1">
+              <a:spcAft>
+                <a:spcPts val="600"/>
+              </a:spcAft>
+              <a:defRPr sz="1300">
+                <a:solidFill>
+                  <a:srgbClr val="6B757D"/>
+                </a:solidFill>
+              </a:defRPr>
+            </a:pPr>
+            <a:r>
+              <a:t>Industry allocation 0.82% + stock selection 3.80% + reference-to-CRSP-market difference 0.18%</a:t>
+            </a:r>
+          </a:p>
+          <a:p>
+            <a:pPr>
+              <a:spcAft>
+                <a:spcPts val="600"/>
+              </a:spcAft>
+              <a:defRPr sz="1500">
+                <a:solidFill>
+                  <a:srgbClr val="1F2A33"/>
+                </a:solidFill>
+              </a:defRPr>
+            </a:pPr>
+            <a:r>
+              <a:t>Reference: cap-weighted formation universe, quarterly constituents and industries fixed, weights drift, delistings to cash</a:t>
+            </a:r>
+          </a:p>
+          <a:p>
+            <a:pPr>
+              <a:spcAft>
+                <a:spcPts val="600"/>
+              </a:spcAft>
+              <a:defRPr sz="1500">
+                <a:solidFill>
+                  <a:srgbClr val="1F2A33"/>
+                </a:solidFill>
+              </a:defRPr>
+            </a:pPr>
+            <a:r>
+              <a:t>Sector variant: 100 slots proportional to industry security counts; apply the rule separately within each FF12 industry. Gross CAGR 14.51%, net-30 13.37%</a:t>
+            </a:r>
+          </a:p>
+          <a:p>
+            <a:pPr>
+              <a:spcAft>
+                <a:spcPts val="600"/>
+              </a:spcAft>
+              <a:defRPr sz="1500">
+                <a:solidFill>
+                  <a:srgbClr val="1F2A33"/>
+                </a:solidFill>
+              </a:defRPr>
+            </a:pPr>
+            <a:r>
+              <a:t>The sector variant is exploratory and changes the paper's global low-volatility screen. Contributions are arithmetic, not causal</a:t>
+            </a:r>
+          </a:p>
+        </p:txBody>
+      </p:sp>
+    </p:spTree>
+  </p:cSld>
+  <p:clrMapOvr>
+    <a:masterClrMapping/>
+  </p:clrMapOvr>
+</p:sld>
+</file>
+
+<file path=ppt/slides/slide13.xml><?xml version="1.0" encoding="utf-8"?>
+<p:sld xmlns:a="http://schemas.openxmlformats.org/drawingml/2006/main" xmlns:p="http://schemas.openxmlformats.org/presentationml/2006/main" xmlns:r="http://schemas.openxmlformats.org/officeDocument/2006/relationships">
+  <p:cSld>
+    <p:spTree>
+      <p:nvGrpSpPr>
+        <p:cNvPr id="1" name=""/>
+        <p:cNvGrpSpPr/>
+        <p:nvPr/>
+      </p:nvGrpSpPr>
+      <p:grpSpPr/>
+      <p:sp>
+        <p:nvSpPr>
+          <p:cNvPr id="2" name="TextBox 1"/>
+          <p:cNvSpPr txBox="1"/>
+          <p:nvPr/>
+        </p:nvSpPr>
+        <p:spPr>
+          <a:xfrm>
+            <a:off x="457200" y="274320"/>
+            <a:ext cx="11247120" cy="822960"/>
+          </a:xfrm>
+          <a:prstGeom prst="rect">
+            <a:avLst/>
+          </a:prstGeom>
+          <a:noFill/>
+        </p:spPr>
+        <p:txBody>
+          <a:bodyPr wrap="square">
+            <a:spAutoFit/>
+          </a:bodyPr>
+          <a:lstStyle/>
+          <a:p>
+            <a:pPr>
+              <a:defRPr sz="2800" b="1">
+                <a:solidFill>
+                  <a:srgbClr val="1F2A33"/>
+                </a:solidFill>
+              </a:defRPr>
+            </a:pPr>
+            <a:r>
               <a:t>Signal diagnostics</a:t>
             </a:r>
           </a:p>
@@ -4899,7 +5444,7 @@
               </a:defRPr>
             </a:pPr>
             <a:r>
-              <a:t>Factor-mimicking paper portfolio: IR 0.50 at K = 1, 0.20 at K = 12</a:t>
+              <a:t>Factor-mimicking paper portfolio: IR 0.59 at K = 1, 0.29 at K = 12</a:t>
             </a:r>
           </a:p>
           <a:p>
@@ -4914,7 +5459,7 @@
               </a:defRPr>
             </a:pPr>
             <a:r>
-              <a:t>2017–2024 IR at K = 1: 0.13</a:t>
+              <a:t>2017–2024 IR at K = 1: 0.29</a:t>
             </a:r>
           </a:p>
           <a:p>
@@ -4966,7 +5511,7 @@
 </p:sld>
 </file>
 
-<file path=ppt/slides/slide12.xml><?xml version="1.0" encoding="utf-8"?>
+<file path=ppt/slides/slide14.xml><?xml version="1.0" encoding="utf-8"?>
 <p:sld xmlns:a="http://schemas.openxmlformats.org/drawingml/2006/main" xmlns:p="http://schemas.openxmlformats.org/presentationml/2006/main" xmlns:r="http://schemas.openxmlformats.org/officeDocument/2006/relationships">
   <p:cSld>
     <p:spTree>
@@ -5074,7 +5619,7 @@
               </a:defRPr>
             </a:pPr>
             <a:r>
-              <a:t>Capacity 2020s ≈ $7.9B (10% of volume at the 95th percentile; no impact model)</a:t>
+              <a:t>Capacity 2020s ≈ $7.9B (scaled to 2024 market size; 10% of volume; no impact model)</a:t>
             </a:r>
           </a:p>
           <a:p>
@@ -5119,14 +5664,14 @@
               </a:defRPr>
             </a:pPr>
             <a:r>
-              <a:t>Further work: quadratic optimization with an estimated covariance model</a:t>
+              <a:t>The next slide adds the assignment's quadratic mean-variance extension</a:t>
             </a:r>
           </a:p>
         </p:txBody>
       </p:sp>
       <p:pic>
         <p:nvPicPr>
-          <p:cNvPr id="4" name="Picture 3" descr="fig_frontier.png"/>
+          <p:cNvPr id="4" name="Picture 3" descr="linear_spec.png"/>
           <p:cNvPicPr>
             <a:picLocks noChangeAspect="1"/>
           </p:cNvPicPr>
@@ -5141,7 +5686,7 @@
         <p:spPr>
           <a:xfrm>
             <a:off x="6126480" y="1280160"/>
-            <a:ext cx="5577840" cy="1673352"/>
+            <a:ext cx="5577840" cy="3824805"/>
           </a:xfrm>
           <a:prstGeom prst="rect">
             <a:avLst/>
@@ -5156,7 +5701,7 @@
 </p:sld>
 </file>
 
-<file path=ppt/slides/slide13.xml><?xml version="1.0" encoding="utf-8"?>
+<file path=ppt/slides/slide15.xml><?xml version="1.0" encoding="utf-8"?>
 <p:sld xmlns:a="http://schemas.openxmlformats.org/drawingml/2006/main" xmlns:p="http://schemas.openxmlformats.org/presentationml/2006/main" xmlns:r="http://schemas.openxmlformats.org/officeDocument/2006/relationships">
   <p:cSld>
     <p:spTree>
@@ -5196,6 +5741,432 @@
               </a:defRPr>
             </a:pPr>
             <a:r>
+              <a:t>Quadratic mean-variance optimization</a:t>
+            </a:r>
+          </a:p>
+        </p:txBody>
+      </p:sp>
+      <p:sp>
+        <p:nvSpPr>
+          <p:cNvPr id="3" name="TextBox 2"/>
+          <p:cNvSpPr txBox="1"/>
+          <p:nvPr/>
+        </p:nvSpPr>
+        <p:spPr>
+          <a:xfrm>
+            <a:off x="457200" y="1280160"/>
+            <a:ext cx="6035040" cy="5212080"/>
+          </a:xfrm>
+          <a:prstGeom prst="rect">
+            <a:avLst/>
+          </a:prstGeom>
+          <a:noFill/>
+        </p:spPr>
+        <p:txBody>
+          <a:bodyPr wrap="square">
+            <a:spAutoFit/>
+          </a:bodyPr>
+          <a:lstStyle/>
+          <a:p>
+            <a:pPr>
+              <a:spcAft>
+                <a:spcPts val="600"/>
+              </a:spcAft>
+              <a:defRPr sz="1300">
+                <a:solidFill>
+                  <a:srgbClr val="1F2A33"/>
+                </a:solidFill>
+              </a:defRPr>
+            </a:pPr>
+            <a:r>
+              <a:t>Maximize expected return − half risk aversion × portfolio variance − trading costs</a:t>
+            </a:r>
+          </a:p>
+          <a:p>
+            <a:pPr>
+              <a:spcAft>
+                <a:spcPts val="600"/>
+              </a:spcAft>
+              <a:defRPr sz="1300">
+                <a:solidFill>
+                  <a:srgbClr val="1F2A33"/>
+                </a:solidFill>
+              </a:defRPr>
+            </a:pPr>
+            <a:r>
+              <a:t>Covariance: trailing 36 monthly returns, 50% diagonal shrinkage; the window ends at formation</a:t>
+            </a:r>
+          </a:p>
+          <a:p>
+            <a:pPr>
+              <a:spcAft>
+                <a:spcPts val="600"/>
+              </a:spcAft>
+              <a:defRPr sz="1300">
+                <a:solidFill>
+                  <a:srgbClr val="1F2A33"/>
+                </a:solidFill>
+              </a:defRPr>
+            </a:pPr>
+            <a:r>
+              <a:t>Return alpha: completed trailing IC × annual volatility × √(3/12) × composite exposure</a:t>
+            </a:r>
+          </a:p>
+          <a:p>
+            <a:pPr>
+              <a:spcAft>
+                <a:spcPts val="600"/>
+              </a:spcAft>
+              <a:defRPr sz="1300">
+                <a:solidFill>
+                  <a:srgbClr val="1F2A33"/>
+                </a:solidFill>
+              </a:defRPr>
+            </a:pPr>
+            <a:r>
+              <a:t>Quarterly: 2% stock cap, industry bands ±5pp, turnover budget 40%; scaled costs start at 30bps</a:t>
+            </a:r>
+          </a:p>
+          <a:p>
+            <a:pPr>
+              <a:spcAft>
+                <a:spcPts val="600"/>
+              </a:spcAft>
+              <a:defRPr sz="1300">
+                <a:solidFill>
+                  <a:srgbClr val="1F2A33"/>
+                </a:solidFill>
+              </a:defRPr>
+            </a:pPr>
+            <a:r>
+              <a:t>Two fixed risk aversions (5 and 20); max constraint violation 4.9e-09; turnover relaxations 0</a:t>
+            </a:r>
+          </a:p>
+          <a:p>
+            <a:pPr>
+              <a:spcAft>
+                <a:spcPts val="600"/>
+              </a:spcAft>
+              <a:defRPr sz="1300">
+                <a:solidFill>
+                  <a:srgbClr val="1F2A33"/>
+                </a:solidFill>
+              </a:defRPr>
+            </a:pPr>
+            <a:r>
+              <a:t>Added during final review after observing the baseline; no unseen test or claim of optimal parameters</a:t>
+            </a:r>
+          </a:p>
+        </p:txBody>
+      </p:sp>
+      <p:graphicFrame>
+        <p:nvGraphicFramePr>
+          <p:cNvPr id="4" name="Table 3"/>
+          <p:cNvGraphicFramePr>
+            <a:graphicFrameLocks noGrp="1"/>
+          </p:cNvGraphicFramePr>
+          <p:nvPr/>
+        </p:nvGraphicFramePr>
+        <p:xfrm>
+          <a:off x="6675120" y="1280160"/>
+          <a:ext cx="5029200" cy="822959"/>
+        </p:xfrm>
+        <a:graphic>
+          <a:graphicData uri="http://schemas.openxmlformats.org/drawingml/2006/table">
+            <a:tbl>
+              <a:tblPr firstRow="1" bandRow="1">
+                <a:tableStyleId>{5C22544A-7EE6-4342-B048-85BDC9FD1C3A}</a:tableStyleId>
+              </a:tblPr>
+              <a:tblGrid>
+                <a:gridCol w="1005840"/>
+                <a:gridCol w="1005840"/>
+                <a:gridCol w="1005840"/>
+                <a:gridCol w="1005840"/>
+                <a:gridCol w="1005840"/>
+              </a:tblGrid>
+              <a:tr h="274319">
+                <a:tc>
+                  <a:txBody>
+                    <a:bodyPr/>
+                    <a:lstStyle/>
+                    <a:p>
+                      <a:pPr>
+                        <a:defRPr sz="1100" b="1"/>
+                      </a:pPr>
+                      <a:r>
+                        <a:t>1990–2024</a:t>
+                      </a:r>
+                    </a:p>
+                  </a:txBody>
+                  <a:tcPr/>
+                </a:tc>
+                <a:tc>
+                  <a:txBody>
+                    <a:bodyPr/>
+                    <a:lstStyle/>
+                    <a:p>
+                      <a:pPr>
+                        <a:defRPr sz="1100" b="1"/>
+                      </a:pPr>
+                      <a:r>
+                        <a:t>Net CAGR</a:t>
+                      </a:r>
+                    </a:p>
+                  </a:txBody>
+                  <a:tcPr/>
+                </a:tc>
+                <a:tc>
+                  <a:txBody>
+                    <a:bodyPr/>
+                    <a:lstStyle/>
+                    <a:p>
+                      <a:pPr>
+                        <a:defRPr sz="1100" b="1"/>
+                      </a:pPr>
+                      <a:r>
+                        <a:t>Volatility</a:t>
+                      </a:r>
+                    </a:p>
+                  </a:txBody>
+                  <a:tcPr/>
+                </a:tc>
+                <a:tc>
+                  <a:txBody>
+                    <a:bodyPr/>
+                    <a:lstStyle/>
+                    <a:p>
+                      <a:pPr>
+                        <a:defRPr sz="1100" b="1"/>
+                      </a:pPr>
+                      <a:r>
+                        <a:t>IR</a:t>
+                      </a:r>
+                    </a:p>
+                  </a:txBody>
+                  <a:tcPr/>
+                </a:tc>
+                <a:tc>
+                  <a:txBody>
+                    <a:bodyPr/>
+                    <a:lstStyle/>
+                    <a:p>
+                      <a:pPr>
+                        <a:defRPr sz="1100" b="1"/>
+                      </a:pPr>
+                      <a:r>
+                        <a:t>Market corr.</a:t>
+                      </a:r>
+                    </a:p>
+                  </a:txBody>
+                  <a:tcPr/>
+                </a:tc>
+              </a:tr>
+              <a:tr h="274319">
+                <a:tc>
+                  <a:txBody>
+                    <a:bodyPr/>
+                    <a:lstStyle/>
+                    <a:p>
+                      <a:pPr>
+                        <a:defRPr sz="1100" b="0"/>
+                      </a:pPr>
+                      <a:r>
+                        <a:t>γ = 5</a:t>
+                      </a:r>
+                    </a:p>
+                  </a:txBody>
+                  <a:tcPr/>
+                </a:tc>
+                <a:tc>
+                  <a:txBody>
+                    <a:bodyPr/>
+                    <a:lstStyle/>
+                    <a:p>
+                      <a:pPr>
+                        <a:defRPr sz="1100" b="0"/>
+                      </a:pPr>
+                      <a:r>
+                        <a:t>11.59%</a:t>
+                      </a:r>
+                    </a:p>
+                  </a:txBody>
+                  <a:tcPr/>
+                </a:tc>
+                <a:tc>
+                  <a:txBody>
+                    <a:bodyPr/>
+                    <a:lstStyle/>
+                    <a:p>
+                      <a:pPr>
+                        <a:defRPr sz="1100" b="0"/>
+                      </a:pPr>
+                      <a:r>
+                        <a:t>12.51%</a:t>
+                      </a:r>
+                    </a:p>
+                  </a:txBody>
+                  <a:tcPr/>
+                </a:tc>
+                <a:tc>
+                  <a:txBody>
+                    <a:bodyPr/>
+                    <a:lstStyle/>
+                    <a:p>
+                      <a:pPr>
+                        <a:defRPr sz="1100" b="0"/>
+                      </a:pPr>
+                      <a:r>
+                        <a:t>0.14</a:t>
+                      </a:r>
+                    </a:p>
+                  </a:txBody>
+                  <a:tcPr/>
+                </a:tc>
+                <a:tc>
+                  <a:txBody>
+                    <a:bodyPr/>
+                    <a:lstStyle/>
+                    <a:p>
+                      <a:pPr>
+                        <a:defRPr sz="1100" b="0"/>
+                      </a:pPr>
+                      <a:r>
+                        <a:t>0.89</a:t>
+                      </a:r>
+                    </a:p>
+                  </a:txBody>
+                  <a:tcPr/>
+                </a:tc>
+              </a:tr>
+              <a:tr h="274321">
+                <a:tc>
+                  <a:txBody>
+                    <a:bodyPr/>
+                    <a:lstStyle/>
+                    <a:p>
+                      <a:pPr>
+                        <a:defRPr sz="1100" b="0"/>
+                      </a:pPr>
+                      <a:r>
+                        <a:t>γ = 20</a:t>
+                      </a:r>
+                    </a:p>
+                  </a:txBody>
+                  <a:tcPr/>
+                </a:tc>
+                <a:tc>
+                  <a:txBody>
+                    <a:bodyPr/>
+                    <a:lstStyle/>
+                    <a:p>
+                      <a:pPr>
+                        <a:defRPr sz="1100" b="0"/>
+                      </a:pPr>
+                      <a:r>
+                        <a:t>10.39%</a:t>
+                      </a:r>
+                    </a:p>
+                  </a:txBody>
+                  <a:tcPr/>
+                </a:tc>
+                <a:tc>
+                  <a:txBody>
+                    <a:bodyPr/>
+                    <a:lstStyle/>
+                    <a:p>
+                      <a:pPr>
+                        <a:defRPr sz="1100" b="0"/>
+                      </a:pPr>
+                      <a:r>
+                        <a:t>11.51%</a:t>
+                      </a:r>
+                    </a:p>
+                  </a:txBody>
+                  <a:tcPr/>
+                </a:tc>
+                <a:tc>
+                  <a:txBody>
+                    <a:bodyPr/>
+                    <a:lstStyle/>
+                    <a:p>
+                      <a:pPr>
+                        <a:defRPr sz="1100" b="0"/>
+                      </a:pPr>
+                      <a:r>
+                        <a:t>−0.03</a:t>
+                      </a:r>
+                    </a:p>
+                  </a:txBody>
+                  <a:tcPr/>
+                </a:tc>
+                <a:tc>
+                  <a:txBody>
+                    <a:bodyPr/>
+                    <a:lstStyle/>
+                    <a:p>
+                      <a:pPr>
+                        <a:defRPr sz="1100" b="0"/>
+                      </a:pPr>
+                      <a:r>
+                        <a:t>0.87</a:t>
+                      </a:r>
+                    </a:p>
+                  </a:txBody>
+                  <a:tcPr/>
+                </a:tc>
+              </a:tr>
+            </a:tbl>
+          </a:graphicData>
+        </a:graphic>
+      </p:graphicFrame>
+    </p:spTree>
+  </p:cSld>
+  <p:clrMapOvr>
+    <a:masterClrMapping/>
+  </p:clrMapOvr>
+</p:sld>
+</file>
+
+<file path=ppt/slides/slide16.xml><?xml version="1.0" encoding="utf-8"?>
+<p:sld xmlns:a="http://schemas.openxmlformats.org/drawingml/2006/main" xmlns:p="http://schemas.openxmlformats.org/presentationml/2006/main" xmlns:r="http://schemas.openxmlformats.org/officeDocument/2006/relationships">
+  <p:cSld>
+    <p:spTree>
+      <p:nvGrpSpPr>
+        <p:cNvPr id="1" name=""/>
+        <p:cNvGrpSpPr/>
+        <p:nvPr/>
+      </p:nvGrpSpPr>
+      <p:grpSpPr/>
+      <p:sp>
+        <p:nvSpPr>
+          <p:cNvPr id="2" name="TextBox 1"/>
+          <p:cNvSpPr txBox="1"/>
+          <p:nvPr/>
+        </p:nvSpPr>
+        <p:spPr>
+          <a:xfrm>
+            <a:off x="457200" y="274320"/>
+            <a:ext cx="11247120" cy="822960"/>
+          </a:xfrm>
+          <a:prstGeom prst="rect">
+            <a:avLst/>
+          </a:prstGeom>
+          <a:noFill/>
+        </p:spPr>
+        <p:txBody>
+          <a:bodyPr wrap="square">
+            <a:spAutoFit/>
+          </a:bodyPr>
+          <a:lstStyle/>
+          <a:p>
+            <a:pPr>
+              <a:defRPr sz="2800" b="1">
+                <a:solidFill>
+                  <a:srgbClr val="1F2A33"/>
+                </a:solidFill>
+              </a:defRPr>
+            </a:pPr>
+            <a:r>
               <a:t>Declared improvement: rank buffer of 150</a:t>
             </a:r>
           </a:p>
@@ -5294,7 +6265,7 @@
               </a:defRPr>
             </a:pPr>
             <a:r>
-              <a:t>Gross difference 0.06%: no signal lost, costs saved</a:t>
+              <a:t>Gross paired difference 0.06%; the observed difference does not prove unchanged signal quality</a:t>
             </a:r>
           </a:p>
           <a:p>
@@ -5346,7 +6317,7 @@
 </p:sld>
 </file>
 
-<file path=ppt/slides/slide14.xml><?xml version="1.0" encoding="utf-8"?>
+<file path=ppt/slides/slide17.xml><?xml version="1.0" encoding="utf-8"?>
 <p:sld xmlns:a="http://schemas.openxmlformats.org/drawingml/2006/main" xmlns:p="http://schemas.openxmlformats.org/presentationml/2006/main" xmlns:r="http://schemas.openxmlformats.org/officeDocument/2006/relationships">
   <p:cSld>
     <p:spTree>
@@ -5512,7 +6483,7 @@
 </p:sld>
 </file>
 
-<file path=ppt/slides/slide15.xml><?xml version="1.0" encoding="utf-8"?>
+<file path=ppt/slides/slide18.xml><?xml version="1.0" encoding="utf-8"?>
 <p:sld xmlns:a="http://schemas.openxmlformats.org/drawingml/2006/main" xmlns:p="http://schemas.openxmlformats.org/presentationml/2006/main" xmlns:r="http://schemas.openxmlformats.org/officeDocument/2006/relationships">
   <p:cSld>
     <p:spTree>
@@ -5665,7 +6636,7 @@
               </a:defRPr>
             </a:pPr>
             <a:r>
-              <a:t>73 result files with sha256 hashes; data manifest 4816d582000a…</a:t>
+              <a:t>85 result files with sha256 hashes; data manifest 4816d582000a…</a:t>
             </a:r>
           </a:p>
         </p:txBody>

</xml_diff>

<commit_message>
Credit Yingni Chang and Yikai Shen across final deliverables
</commit_message>
<xml_diff>
--- a/Final/presentation/conservative_formula.pptx
+++ b/Final/presentation/conservative_formula.pptx
@@ -4757,7 +4757,7 @@
               </a:defRPr>
             </a:pPr>
             <a:r>
-              <a:t>Yingni Chang · MTH 9897 Project 8 · CRSP replication, 1929–2024</a:t>
+              <a:t>Yingni Chang and Yikai Shen · MTH 9897 Project 8 · CRSP replication, 1929–2024</a:t>
             </a:r>
           </a:p>
         </p:txBody>
@@ -4841,6 +4841,41 @@
             </a:pPr>
             <a:r>
               <a:t>Headline period: 1990–2024 (2017–2024 is post-sample)</a:t>
+            </a:r>
+          </a:p>
+        </p:txBody>
+      </p:sp>
+      <p:sp>
+        <p:nvSpPr>
+          <p:cNvPr id="4" name="TextBox 3"/>
+          <p:cNvSpPr txBox="1"/>
+          <p:nvPr/>
+        </p:nvSpPr>
+        <p:spPr>
+          <a:xfrm>
+            <a:off x="457200" y="6537960"/>
+            <a:ext cx="11247120" cy="219456"/>
+          </a:xfrm>
+          <a:prstGeom prst="rect">
+            <a:avLst/>
+          </a:prstGeom>
+          <a:noFill/>
+        </p:spPr>
+        <p:txBody>
+          <a:bodyPr wrap="none" tIns="0" bIns="0">
+            <a:spAutoFit/>
+          </a:bodyPr>
+          <a:lstStyle/>
+          <a:p>
+            <a:pPr>
+              <a:defRPr sz="900">
+                <a:solidFill>
+                  <a:srgbClr val="6B757D"/>
+                </a:solidFill>
+              </a:defRPr>
+            </a:pPr>
+            <a:r>
+              <a:t>Yingni Chang and Yikai Shen</a:t>
             </a:r>
           </a:p>
         </p:txBody>
@@ -4996,6 +5031,41 @@
           </a:p>
         </p:txBody>
       </p:sp>
+      <p:sp>
+        <p:nvSpPr>
+          <p:cNvPr id="4" name="TextBox 3"/>
+          <p:cNvSpPr txBox="1"/>
+          <p:nvPr/>
+        </p:nvSpPr>
+        <p:spPr>
+          <a:xfrm>
+            <a:off x="457200" y="6537960"/>
+            <a:ext cx="11247120" cy="219456"/>
+          </a:xfrm>
+          <a:prstGeom prst="rect">
+            <a:avLst/>
+          </a:prstGeom>
+          <a:noFill/>
+        </p:spPr>
+        <p:txBody>
+          <a:bodyPr wrap="none" tIns="0" bIns="0">
+            <a:spAutoFit/>
+          </a:bodyPr>
+          <a:lstStyle/>
+          <a:p>
+            <a:pPr>
+              <a:defRPr sz="900">
+                <a:solidFill>
+                  <a:srgbClr val="6B757D"/>
+                </a:solidFill>
+              </a:defRPr>
+            </a:pPr>
+            <a:r>
+              <a:t>Yingni Chang and Yikai Shen</a:t>
+            </a:r>
+          </a:p>
+        </p:txBody>
+      </p:sp>
     </p:spTree>
   </p:cSld>
   <p:clrMapOvr>
@@ -5162,6 +5232,41 @@
           </a:p>
         </p:txBody>
       </p:sp>
+      <p:sp>
+        <p:nvSpPr>
+          <p:cNvPr id="4" name="TextBox 3"/>
+          <p:cNvSpPr txBox="1"/>
+          <p:nvPr/>
+        </p:nvSpPr>
+        <p:spPr>
+          <a:xfrm>
+            <a:off x="457200" y="6537960"/>
+            <a:ext cx="11247120" cy="219456"/>
+          </a:xfrm>
+          <a:prstGeom prst="rect">
+            <a:avLst/>
+          </a:prstGeom>
+          <a:noFill/>
+        </p:spPr>
+        <p:txBody>
+          <a:bodyPr wrap="none" tIns="0" bIns="0">
+            <a:spAutoFit/>
+          </a:bodyPr>
+          <a:lstStyle/>
+          <a:p>
+            <a:pPr>
+              <a:defRPr sz="900">
+                <a:solidFill>
+                  <a:srgbClr val="6B757D"/>
+                </a:solidFill>
+              </a:defRPr>
+            </a:pPr>
+            <a:r>
+              <a:t>Yingni Chang and Yikai Shen</a:t>
+            </a:r>
+          </a:p>
+        </p:txBody>
+      </p:sp>
     </p:spTree>
   </p:cSld>
   <p:clrMapOvr>
@@ -5324,6 +5429,41 @@
             </a:pPr>
             <a:r>
               <a:t>The sector variant is exploratory and changes the paper's global low-volatility screen. Contributions are arithmetic, not causal</a:t>
+            </a:r>
+          </a:p>
+        </p:txBody>
+      </p:sp>
+      <p:sp>
+        <p:nvSpPr>
+          <p:cNvPr id="4" name="TextBox 3"/>
+          <p:cNvSpPr txBox="1"/>
+          <p:nvPr/>
+        </p:nvSpPr>
+        <p:spPr>
+          <a:xfrm>
+            <a:off x="457200" y="6537960"/>
+            <a:ext cx="11247120" cy="219456"/>
+          </a:xfrm>
+          <a:prstGeom prst="rect">
+            <a:avLst/>
+          </a:prstGeom>
+          <a:noFill/>
+        </p:spPr>
+        <p:txBody>
+          <a:bodyPr wrap="none" tIns="0" bIns="0">
+            <a:spAutoFit/>
+          </a:bodyPr>
+          <a:lstStyle/>
+          <a:p>
+            <a:pPr>
+              <a:defRPr sz="900">
+                <a:solidFill>
+                  <a:srgbClr val="6B757D"/>
+                </a:solidFill>
+              </a:defRPr>
+            </a:pPr>
+            <a:r>
+              <a:t>Yingni Chang and Yikai Shen</a:t>
             </a:r>
           </a:p>
         </p:txBody>
@@ -5503,6 +5643,41 @@
           </a:prstGeom>
         </p:spPr>
       </p:pic>
+      <p:sp>
+        <p:nvSpPr>
+          <p:cNvPr id="5" name="TextBox 4"/>
+          <p:cNvSpPr txBox="1"/>
+          <p:nvPr/>
+        </p:nvSpPr>
+        <p:spPr>
+          <a:xfrm>
+            <a:off x="457200" y="6537960"/>
+            <a:ext cx="11247120" cy="219456"/>
+          </a:xfrm>
+          <a:prstGeom prst="rect">
+            <a:avLst/>
+          </a:prstGeom>
+          <a:noFill/>
+        </p:spPr>
+        <p:txBody>
+          <a:bodyPr wrap="none" tIns="0" bIns="0">
+            <a:spAutoFit/>
+          </a:bodyPr>
+          <a:lstStyle/>
+          <a:p>
+            <a:pPr>
+              <a:defRPr sz="900">
+                <a:solidFill>
+                  <a:srgbClr val="6B757D"/>
+                </a:solidFill>
+              </a:defRPr>
+            </a:pPr>
+            <a:r>
+              <a:t>Yingni Chang and Yikai Shen</a:t>
+            </a:r>
+          </a:p>
+        </p:txBody>
+      </p:sp>
     </p:spTree>
   </p:cSld>
   <p:clrMapOvr>
@@ -5693,6 +5868,41 @@
           </a:prstGeom>
         </p:spPr>
       </p:pic>
+      <p:sp>
+        <p:nvSpPr>
+          <p:cNvPr id="5" name="TextBox 4"/>
+          <p:cNvSpPr txBox="1"/>
+          <p:nvPr/>
+        </p:nvSpPr>
+        <p:spPr>
+          <a:xfrm>
+            <a:off x="457200" y="6537960"/>
+            <a:ext cx="11247120" cy="219456"/>
+          </a:xfrm>
+          <a:prstGeom prst="rect">
+            <a:avLst/>
+          </a:prstGeom>
+          <a:noFill/>
+        </p:spPr>
+        <p:txBody>
+          <a:bodyPr wrap="none" tIns="0" bIns="0">
+            <a:spAutoFit/>
+          </a:bodyPr>
+          <a:lstStyle/>
+          <a:p>
+            <a:pPr>
+              <a:defRPr sz="900">
+                <a:solidFill>
+                  <a:srgbClr val="6B757D"/>
+                </a:solidFill>
+              </a:defRPr>
+            </a:pPr>
+            <a:r>
+              <a:t>Yingni Chang and Yikai Shen</a:t>
+            </a:r>
+          </a:p>
+        </p:txBody>
+      </p:sp>
     </p:spTree>
   </p:cSld>
   <p:clrMapOvr>
@@ -6119,6 +6329,41 @@
           </a:graphicData>
         </a:graphic>
       </p:graphicFrame>
+      <p:sp>
+        <p:nvSpPr>
+          <p:cNvPr id="5" name="TextBox 4"/>
+          <p:cNvSpPr txBox="1"/>
+          <p:nvPr/>
+        </p:nvSpPr>
+        <p:spPr>
+          <a:xfrm>
+            <a:off x="457200" y="6537960"/>
+            <a:ext cx="11247120" cy="219456"/>
+          </a:xfrm>
+          <a:prstGeom prst="rect">
+            <a:avLst/>
+          </a:prstGeom>
+          <a:noFill/>
+        </p:spPr>
+        <p:txBody>
+          <a:bodyPr wrap="none" tIns="0" bIns="0">
+            <a:spAutoFit/>
+          </a:bodyPr>
+          <a:lstStyle/>
+          <a:p>
+            <a:pPr>
+              <a:defRPr sz="900">
+                <a:solidFill>
+                  <a:srgbClr val="6B757D"/>
+                </a:solidFill>
+              </a:defRPr>
+            </a:pPr>
+            <a:r>
+              <a:t>Yingni Chang and Yikai Shen</a:t>
+            </a:r>
+          </a:p>
+        </p:txBody>
+      </p:sp>
     </p:spTree>
   </p:cSld>
   <p:clrMapOvr>
@@ -6309,6 +6554,41 @@
           </a:prstGeom>
         </p:spPr>
       </p:pic>
+      <p:sp>
+        <p:nvSpPr>
+          <p:cNvPr id="5" name="TextBox 4"/>
+          <p:cNvSpPr txBox="1"/>
+          <p:nvPr/>
+        </p:nvSpPr>
+        <p:spPr>
+          <a:xfrm>
+            <a:off x="457200" y="6537960"/>
+            <a:ext cx="11247120" cy="219456"/>
+          </a:xfrm>
+          <a:prstGeom prst="rect">
+            <a:avLst/>
+          </a:prstGeom>
+          <a:noFill/>
+        </p:spPr>
+        <p:txBody>
+          <a:bodyPr wrap="none" tIns="0" bIns="0">
+            <a:spAutoFit/>
+          </a:bodyPr>
+          <a:lstStyle/>
+          <a:p>
+            <a:pPr>
+              <a:defRPr sz="900">
+                <a:solidFill>
+                  <a:srgbClr val="6B757D"/>
+                </a:solidFill>
+              </a:defRPr>
+            </a:pPr>
+            <a:r>
+              <a:t>Yingni Chang and Yikai Shen</a:t>
+            </a:r>
+          </a:p>
+        </p:txBody>
+      </p:sp>
     </p:spTree>
   </p:cSld>
   <p:clrMapOvr>
@@ -6475,6 +6755,41 @@
           </a:p>
         </p:txBody>
       </p:sp>
+      <p:sp>
+        <p:nvSpPr>
+          <p:cNvPr id="4" name="TextBox 3"/>
+          <p:cNvSpPr txBox="1"/>
+          <p:nvPr/>
+        </p:nvSpPr>
+        <p:spPr>
+          <a:xfrm>
+            <a:off x="457200" y="6537960"/>
+            <a:ext cx="11247120" cy="219456"/>
+          </a:xfrm>
+          <a:prstGeom prst="rect">
+            <a:avLst/>
+          </a:prstGeom>
+          <a:noFill/>
+        </p:spPr>
+        <p:txBody>
+          <a:bodyPr wrap="none" tIns="0" bIns="0">
+            <a:spAutoFit/>
+          </a:bodyPr>
+          <a:lstStyle/>
+          <a:p>
+            <a:pPr>
+              <a:defRPr sz="900">
+                <a:solidFill>
+                  <a:srgbClr val="6B757D"/>
+                </a:solidFill>
+              </a:defRPr>
+            </a:pPr>
+            <a:r>
+              <a:t>Yingni Chang and Yikai Shen</a:t>
+            </a:r>
+          </a:p>
+        </p:txBody>
+      </p:sp>
     </p:spTree>
   </p:cSld>
   <p:clrMapOvr>
@@ -6641,6 +6956,41 @@
           </a:p>
         </p:txBody>
       </p:sp>
+      <p:sp>
+        <p:nvSpPr>
+          <p:cNvPr id="4" name="TextBox 3"/>
+          <p:cNvSpPr txBox="1"/>
+          <p:nvPr/>
+        </p:nvSpPr>
+        <p:spPr>
+          <a:xfrm>
+            <a:off x="457200" y="6537960"/>
+            <a:ext cx="11247120" cy="219456"/>
+          </a:xfrm>
+          <a:prstGeom prst="rect">
+            <a:avLst/>
+          </a:prstGeom>
+          <a:noFill/>
+        </p:spPr>
+        <p:txBody>
+          <a:bodyPr wrap="none" tIns="0" bIns="0">
+            <a:spAutoFit/>
+          </a:bodyPr>
+          <a:lstStyle/>
+          <a:p>
+            <a:pPr>
+              <a:defRPr sz="900">
+                <a:solidFill>
+                  <a:srgbClr val="6B757D"/>
+                </a:solidFill>
+              </a:defRPr>
+            </a:pPr>
+            <a:r>
+              <a:t>Yingni Chang and Yikai Shen</a:t>
+            </a:r>
+          </a:p>
+        </p:txBody>
+      </p:sp>
     </p:spTree>
   </p:cSld>
   <p:clrMapOvr>
@@ -6792,6 +7142,41 @@
           </a:p>
         </p:txBody>
       </p:sp>
+      <p:sp>
+        <p:nvSpPr>
+          <p:cNvPr id="4" name="TextBox 3"/>
+          <p:cNvSpPr txBox="1"/>
+          <p:nvPr/>
+        </p:nvSpPr>
+        <p:spPr>
+          <a:xfrm>
+            <a:off x="457200" y="6537960"/>
+            <a:ext cx="11247120" cy="219456"/>
+          </a:xfrm>
+          <a:prstGeom prst="rect">
+            <a:avLst/>
+          </a:prstGeom>
+          <a:noFill/>
+        </p:spPr>
+        <p:txBody>
+          <a:bodyPr wrap="none" tIns="0" bIns="0">
+            <a:spAutoFit/>
+          </a:bodyPr>
+          <a:lstStyle/>
+          <a:p>
+            <a:pPr>
+              <a:defRPr sz="900">
+                <a:solidFill>
+                  <a:srgbClr val="6B757D"/>
+                </a:solidFill>
+              </a:defRPr>
+            </a:pPr>
+            <a:r>
+              <a:t>Yingni Chang and Yikai Shen</a:t>
+            </a:r>
+          </a:p>
+        </p:txBody>
+      </p:sp>
     </p:spTree>
   </p:cSld>
   <p:clrMapOvr>
@@ -6954,6 +7339,41 @@
             </a:pPr>
             <a:r>
               <a:t>No release identifier on WRDS: the extract is identified by time stamp and file hashes</a:t>
+            </a:r>
+          </a:p>
+        </p:txBody>
+      </p:sp>
+      <p:sp>
+        <p:nvSpPr>
+          <p:cNvPr id="4" name="TextBox 3"/>
+          <p:cNvSpPr txBox="1"/>
+          <p:nvPr/>
+        </p:nvSpPr>
+        <p:spPr>
+          <a:xfrm>
+            <a:off x="457200" y="6537960"/>
+            <a:ext cx="11247120" cy="219456"/>
+          </a:xfrm>
+          <a:prstGeom prst="rect">
+            <a:avLst/>
+          </a:prstGeom>
+          <a:noFill/>
+        </p:spPr>
+        <p:txBody>
+          <a:bodyPr wrap="none" tIns="0" bIns="0">
+            <a:spAutoFit/>
+          </a:bodyPr>
+          <a:lstStyle/>
+          <a:p>
+            <a:pPr>
+              <a:defRPr sz="900">
+                <a:solidFill>
+                  <a:srgbClr val="6B757D"/>
+                </a:solidFill>
+              </a:defRPr>
+            </a:pPr>
+            <a:r>
+              <a:t>Yingni Chang and Yikai Shen</a:t>
             </a:r>
           </a:p>
         </p:txBody>
@@ -7344,6 +7764,41 @@
           </a:graphicData>
         </a:graphic>
       </p:graphicFrame>
+      <p:sp>
+        <p:nvSpPr>
+          <p:cNvPr id="5" name="TextBox 4"/>
+          <p:cNvSpPr txBox="1"/>
+          <p:nvPr/>
+        </p:nvSpPr>
+        <p:spPr>
+          <a:xfrm>
+            <a:off x="457200" y="6537960"/>
+            <a:ext cx="11247120" cy="219456"/>
+          </a:xfrm>
+          <a:prstGeom prst="rect">
+            <a:avLst/>
+          </a:prstGeom>
+          <a:noFill/>
+        </p:spPr>
+        <p:txBody>
+          <a:bodyPr wrap="none" tIns="0" bIns="0">
+            <a:spAutoFit/>
+          </a:bodyPr>
+          <a:lstStyle/>
+          <a:p>
+            <a:pPr>
+              <a:defRPr sz="900">
+                <a:solidFill>
+                  <a:srgbClr val="6B757D"/>
+                </a:solidFill>
+              </a:defRPr>
+            </a:pPr>
+            <a:r>
+              <a:t>Yingni Chang and Yikai Shen</a:t>
+            </a:r>
+          </a:p>
+        </p:txBody>
+      </p:sp>
     </p:spTree>
   </p:cSld>
   <p:clrMapOvr>
@@ -7506,6 +7961,41 @@
             </a:pPr>
             <a:r>
               <a:t>Quarter-end information determines next month's holdings. No forward return enters selection.</a:t>
+            </a:r>
+          </a:p>
+        </p:txBody>
+      </p:sp>
+      <p:sp>
+        <p:nvSpPr>
+          <p:cNvPr id="4" name="TextBox 3"/>
+          <p:cNvSpPr txBox="1"/>
+          <p:nvPr/>
+        </p:nvSpPr>
+        <p:spPr>
+          <a:xfrm>
+            <a:off x="457200" y="6537960"/>
+            <a:ext cx="11247120" cy="219456"/>
+          </a:xfrm>
+          <a:prstGeom prst="rect">
+            <a:avLst/>
+          </a:prstGeom>
+          <a:noFill/>
+        </p:spPr>
+        <p:txBody>
+          <a:bodyPr wrap="none" tIns="0" bIns="0">
+            <a:spAutoFit/>
+          </a:bodyPr>
+          <a:lstStyle/>
+          <a:p>
+            <a:pPr>
+              <a:defRPr sz="900">
+                <a:solidFill>
+                  <a:srgbClr val="6B757D"/>
+                </a:solidFill>
+              </a:defRPr>
+            </a:pPr>
+            <a:r>
+              <a:t>Yingni Chang and Yikai Shen</a:t>
             </a:r>
           </a:p>
         </p:txBody>
@@ -8037,6 +8527,41 @@
           </a:graphicData>
         </a:graphic>
       </p:graphicFrame>
+      <p:sp>
+        <p:nvSpPr>
+          <p:cNvPr id="6" name="TextBox 5"/>
+          <p:cNvSpPr txBox="1"/>
+          <p:nvPr/>
+        </p:nvSpPr>
+        <p:spPr>
+          <a:xfrm>
+            <a:off x="457200" y="6537960"/>
+            <a:ext cx="11247120" cy="219456"/>
+          </a:xfrm>
+          <a:prstGeom prst="rect">
+            <a:avLst/>
+          </a:prstGeom>
+          <a:noFill/>
+        </p:spPr>
+        <p:txBody>
+          <a:bodyPr wrap="none" tIns="0" bIns="0">
+            <a:spAutoFit/>
+          </a:bodyPr>
+          <a:lstStyle/>
+          <a:p>
+            <a:pPr>
+              <a:defRPr sz="900">
+                <a:solidFill>
+                  <a:srgbClr val="6B757D"/>
+                </a:solidFill>
+              </a:defRPr>
+            </a:pPr>
+            <a:r>
+              <a:t>Yingni Chang and Yikai Shen</a:t>
+            </a:r>
+          </a:p>
+        </p:txBody>
+      </p:sp>
     </p:spTree>
   </p:cSld>
   <p:clrMapOvr>
@@ -8184,6 +8709,41 @@
             </a:pPr>
             <a:r>
               <a:t>CMS net of 30 bps, both legs paying: Carhart 5.78% (t 3.99)</a:t>
+            </a:r>
+          </a:p>
+        </p:txBody>
+      </p:sp>
+      <p:sp>
+        <p:nvSpPr>
+          <p:cNvPr id="4" name="TextBox 3"/>
+          <p:cNvSpPr txBox="1"/>
+          <p:nvPr/>
+        </p:nvSpPr>
+        <p:spPr>
+          <a:xfrm>
+            <a:off x="457200" y="6537960"/>
+            <a:ext cx="11247120" cy="219456"/>
+          </a:xfrm>
+          <a:prstGeom prst="rect">
+            <a:avLst/>
+          </a:prstGeom>
+          <a:noFill/>
+        </p:spPr>
+        <p:txBody>
+          <a:bodyPr wrap="none" tIns="0" bIns="0">
+            <a:spAutoFit/>
+          </a:bodyPr>
+          <a:lstStyle/>
+          <a:p>
+            <a:pPr>
+              <a:defRPr sz="900">
+                <a:solidFill>
+                  <a:srgbClr val="6B757D"/>
+                </a:solidFill>
+              </a:defRPr>
+            </a:pPr>
+            <a:r>
+              <a:t>Yingni Chang and Yikai Shen</a:t>
             </a:r>
           </a:p>
         </p:txBody>
@@ -8648,6 +9208,41 @@
           </a:graphicData>
         </a:graphic>
       </p:graphicFrame>
+      <p:sp>
+        <p:nvSpPr>
+          <p:cNvPr id="5" name="TextBox 4"/>
+          <p:cNvSpPr txBox="1"/>
+          <p:nvPr/>
+        </p:nvSpPr>
+        <p:spPr>
+          <a:xfrm>
+            <a:off x="457200" y="6537960"/>
+            <a:ext cx="11247120" cy="219456"/>
+          </a:xfrm>
+          <a:prstGeom prst="rect">
+            <a:avLst/>
+          </a:prstGeom>
+          <a:noFill/>
+        </p:spPr>
+        <p:txBody>
+          <a:bodyPr wrap="none" tIns="0" bIns="0">
+            <a:spAutoFit/>
+          </a:bodyPr>
+          <a:lstStyle/>
+          <a:p>
+            <a:pPr>
+              <a:defRPr sz="900">
+                <a:solidFill>
+                  <a:srgbClr val="6B757D"/>
+                </a:solidFill>
+              </a:defRPr>
+            </a:pPr>
+            <a:r>
+              <a:t>Yingni Chang and Yikai Shen</a:t>
+            </a:r>
+          </a:p>
+        </p:txBody>
+      </p:sp>
     </p:spTree>
   </p:cSld>
   <p:clrMapOvr>
@@ -9284,6 +9879,41 @@
           </a:graphicData>
         </a:graphic>
       </p:graphicFrame>
+      <p:sp>
+        <p:nvSpPr>
+          <p:cNvPr id="6" name="TextBox 5"/>
+          <p:cNvSpPr txBox="1"/>
+          <p:nvPr/>
+        </p:nvSpPr>
+        <p:spPr>
+          <a:xfrm>
+            <a:off x="457200" y="6537960"/>
+            <a:ext cx="11247120" cy="219456"/>
+          </a:xfrm>
+          <a:prstGeom prst="rect">
+            <a:avLst/>
+          </a:prstGeom>
+          <a:noFill/>
+        </p:spPr>
+        <p:txBody>
+          <a:bodyPr wrap="none" tIns="0" bIns="0">
+            <a:spAutoFit/>
+          </a:bodyPr>
+          <a:lstStyle/>
+          <a:p>
+            <a:pPr>
+              <a:defRPr sz="900">
+                <a:solidFill>
+                  <a:srgbClr val="6B757D"/>
+                </a:solidFill>
+              </a:defRPr>
+            </a:pPr>
+            <a:r>
+              <a:t>Yingni Chang and Yikai Shen</a:t>
+            </a:r>
+          </a:p>
+        </p:txBody>
+      </p:sp>
     </p:spTree>
   </p:cSld>
   <p:clrMapOvr>

</xml_diff>

<commit_message>
Revise project writing and layout for a clearer research voice
</commit_message>
<xml_diff>
--- a/Final/presentation/conservative_formula.pptx
+++ b/Final/presentation/conservative_formula.pptx
@@ -519,7 +519,7 @@
           <a:lstStyle/>
           <a:p>
             <a:r>
-              <a:t>The replication is the benchmark, not the conclusion. The three questions and their periods were fixed before any 2017–2024 return was computed; the first load of those data is time-stamped 2026-10-11T00:50:37+00:00.</a:t>
+              <a:t>We use monthly CRSP data to implement the paper's rule, then extend the backtest through 2024. The first comparison uses the paper's own sample. The later analysis asks whether the return survives factor adjustment and trading costs.</a:t>
             </a:r>
           </a:p>
         </p:txBody>
@@ -589,7 +589,7 @@
           <a:lstStyle/>
           <a:p>
             <a:r>
-              <a:t>The evidence does not support the claim that the formula beats the market on recent data once known factors and realistic costs are taken into account.</a:t>
+              <a:t>After costs, the recent alpha interval includes zero. The portfolio still has lower volatility than the market. The Conservative-minus-Speculative contrast remains different from the long-only portfolio's performance against the market.</a:t>
             </a:r>
           </a:p>
         </p:txBody>
@@ -659,7 +659,7 @@
           <a:lstStyle/>
           <a:p>
             <a:r>
-              <a:t>This directly addresses the professor's payout warning. The latest/24-month-average share ratio comes from paper page 4; the 12-month dividend window is a disclosed convention. The review adds synthetic tests for repurchases, issuance and split neutrality, plus 1,200 independent signal calculations.</a:t>
+              <a:t>This is the payout issue raised in the assignment. We compare NPY with dividends alone using otherwise identical portfolio rules. The share-count term changes both selections and returns. It measures net repurchases after issuance, rather than reported buyback cash spending.</a:t>
             </a:r>
           </a:p>
         </p:txBody>
@@ -729,7 +729,7 @@
           <a:lstStyle/>
           <a:p>
             <a:r>
-              <a:t>Exact monthly allocation plus selection plus the universe-to-market bridge reconciles to baseline excess returns. Selection includes interaction. The quota rule follows the professor's Enhanced Momentum example, using counts rather than cap weights, largest-remainder rounding and equal stock weights.</a:t>
+              <a:t>We compare with the same formation universe so that industry allocation is not confused with a broad-market universe difference. The attribution includes the selection interaction. We then apply the course's count-proportional quotas, which change the paper's global screen.</a:t>
             </a:r>
           </a:p>
         </p:txBody>
@@ -799,7 +799,7 @@
           <a:lstStyle/>
           <a:p>
             <a:r>
-              <a:t>Signals are industry-neutralized, standardized and clipped at ±3; returns are industry-adjusted.</a:t>
+              <a:t>These tests use industry-neutral exposures and industry-adjusted returns. Rank IC and a mean decile spread can tell different stories when returns are skewed. The factor-mimicking portfolios are gross diagnostic portfolios and may have substantial leverage.</a:t>
             </a:r>
           </a:p>
         </p:txBody>
@@ -869,7 +869,7 @@
           <a:lstStyle/>
           <a:p>
             <a:r>
-              <a:t>Labels matter: the long/short convention and the optimizer's alpha-scaling sensitivity were chosen after results were seen.</a:t>
+              <a:t>The initial buy-and-hold long/short loses all capital in the early data. Monthly reweighting was considered after seeing that outcome, and still gives severe drawdowns. The linear optimizer results also need caution: the displayed intervals are unadjusted for testing several settings.</a:t>
             </a:r>
           </a:p>
         </p:txBody>
@@ -939,7 +939,7 @@
           <a:lstStyle/>
           <a:p>
             <a:r>
-              <a:t>This fulfills the quadratic optimization requirement using an estimated risk model. A positive semidefinite 50% diagonal shrinkage estimate regularizes 1,000 stocks with 36 observations. Covariance is scaled to three months assuming no autocorrelation. Both gamma values and all feasibility relaxations are reported in the notebook. These are long-only portfolios with substantial market exposure.</a:t>
+              <a:t>With only 36 observations for about 1,000 stocks, sample covariance needs regularization. We use half sample covariance and half diagonal covariance. More risk aversion lowers realized volatility, but these long-only portfolios remain highly correlated with the market. We chose these settings after examining the baseline.</a:t>
             </a:r>
           </a:p>
         </p:txBody>
@@ -1009,7 +1009,7 @@
           <a:lstStyle/>
           <a:p>
             <a:r>
-              <a:t>The buffer recovers part of the cost drag but does not change the answer to the critical tests.</a:t>
+              <a:t>We fixed the 150-rank buffer before testing it. It reduces turnover, and its net point estimate is positive, but the paired interval includes zero. Since it also changes holdings, we cannot attribute the entire difference to cost savings.</a:t>
             </a:r>
           </a:p>
         </p:txBody>
@@ -1079,7 +1079,7 @@
           <a:lstStyle/>
           <a:p>
             <a:r>
-              <a:t>These statements follow the accepted conclusions of the replication, attribution and critical tests.</a:t>
+              <a:t>We reproduce much of the historical return-and-risk pattern. The remaining turnover and regression gaps prevent an exact replication claim. For recent data, lower volatility is more consistent than positive net alpha. The extra strategies need an unseen test before stronger claims would be justified.</a:t>
             </a:r>
           </a:p>
         </p:txBody>
@@ -1149,7 +1149,7 @@
           <a:lstStyle/>
           <a:p>
             <a:r>
-              <a:t>Every slide number is read from results/ through the loader, which refuses a file whose hash differs from the manifest. Security-level rows stay in the git-ignored output/ folder.</a:t>
+              <a:t>The notebook and both PDFs read saved aggregate results. The full calculation starts with the private CRSP inputs and runs through research.run_all. Source data, cleaning audits and run instructions are included in the private submission package.</a:t>
             </a:r>
           </a:p>
         </p:txBody>
@@ -1219,7 +1219,7 @@
           <a:lstStyle/>
           <a:p>
             <a:r>
-              <a:t>CAPM alphas are shown only for comparison with the paper. A positive average return is not treated as evidence unless its interval excludes zero.</a:t>
+              <a:t>We compare the published return and risk first. Then we examine known factors, changes across periods and trading costs. These comparisons were fixed before computing the post-2016 portfolio returns. The additional variants are separate experiments.</a:t>
             </a:r>
           </a:p>
         </p:txBody>
@@ -1289,7 +1289,7 @@
           <a:lstStyle/>
           <a:p>
             <a:r>
-              <a:t>All audit tables (coverage, exclusions, missing returns, delistings, dividends, benchmark) are in the notebook's data section; no security-level row appears in the report.</a:t>
+              <a:t>The data work matters here. We retain delisted stocks, use historical company and exchange information, and separate missing signal inputs from returns on already-held positions. The early universe is much smaller than 1,000 names.</a:t>
             </a:r>
           </a:p>
         </p:txBody>
@@ -1359,7 +1359,7 @@
           <a:lstStyle/>
           <a:p>
             <a:r>
-              <a:t>Every deviation is disclosed with its direction or magnitude in the notebook's deviations table.</a:t>
+              <a:t>We require 36 months of return history before the size cut. After that, we use the low-volatility half and combine momentum and payout ranks. The largest share class represents each company. We document the choices that the paper leaves open.</a:t>
             </a:r>
           </a:p>
         </p:txBody>
@@ -1429,7 +1429,7 @@
           <a:lstStyle/>
           <a:p>
             <a:r>
-              <a:t>The 12-month dividend window is a disclosed convention: the paper specifies the share-count ratio but does not fully specify the dividend window. Price returns exclude distributions; total returns include them. Adjusting both prices and shares prevents a stock split from looking like a buyback.</a:t>
+              <a:t>Momentum uses price returns and excludes the latest month. Portfolio returns include distributions. For payout, both prices and shares need split adjustment: a split should not appear as a repurchase. The 12-month dividend window is our disclosed convention.</a:t>
             </a:r>
           </a:p>
         </p:txBody>
@@ -1499,7 +1499,7 @@
           <a:lstStyle/>
           <a:p>
             <a:r>
-              <a:t>Gross of costs, paper definitions. Candidate explanations and unresolved material gaps are listed in the notebook; no parameter was adjusted to force agreement with the paper.</a:t>
+              <a:t>The main return and volatility figures are close. The turnover difference is larger and remains unresolved. We have not changed the rule to force agreement. Share classes, the size measure and payout estimation may affect the result, but we cannot separate their effects.</a:t>
             </a:r>
           </a:p>
         </p:txBody>
@@ -1569,7 +1569,7 @@
           <a:lstStyle/>
           <a:p>
             <a:r>
-              <a:t>Paper t-values are compared with our OLS t; Newey–West t-statistics are reported alongside in the notebook.</a:t>
+              <a:t>The factor model changes the interpretation of the historical return. Adding profitability and investment reduces estimated alpha substantially. The post-1963 comparisons are closer than the full-sample ones; a different sample should not be mistaken for evidence of the cause of the gap.</a:t>
             </a:r>
           </a:p>
         </p:txBody>
@@ -1639,7 +1639,7 @@
           <a:lstStyle/>
           <a:p>
             <a:r>
-              <a:t>Break-even is the cost per dollar traded at which the net excess return or net Carhart alpha reaches zero.</a:t>
+              <a:t>We charge both purchases and sales. Break-even is the cost per dollar traded at which market excess return or Carhart alpha reaches zero. Flat cost scenarios do not capture historical changes in liquidity or market impact.</a:t>
             </a:r>
           </a:p>
         </p:txBody>
@@ -1709,7 +1709,7 @@
           <a:lstStyle/>
           <a:p>
             <a:r>
-              <a:t>No evidence of outperformance in 2017–2024, rather than proof of failure: the interval is wide.</a:t>
+              <a:t>The earlier estimates are stronger than the recent ones. The sample after 2016 is only eight years, so its interval is wide. We do not interpret an insignificant estimate as proof that expected alpha is exactly zero.</a:t>
             </a:r>
           </a:p>
         </p:txBody>
@@ -4745,7 +4745,7 @@
               </a:defRPr>
             </a:pPr>
             <a:r>
-              <a:t>The Conservative Formula</a:t>
+              <a:t>Replicating the Conservative Formula</a:t>
             </a:r>
           </a:p>
           <a:p>
@@ -4825,7 +4825,7 @@
               </a:defRPr>
             </a:pPr>
             <a:r>
-              <a:t>Then test three questions fixed in advance: known factors, decay, costs</a:t>
+              <a:t>Then examine factor exposure, later periods and trading costs</a:t>
             </a:r>
           </a:p>
           <a:p>
@@ -4840,7 +4840,7 @@
               </a:defRPr>
             </a:pPr>
             <a:r>
-              <a:t>Headline period: 1990–2024 (2017–2024 is post-sample)</a:t>
+              <a:t>Main recent comparison: 1990–2024; the paper ends in 2016</a:t>
             </a:r>
           </a:p>
         </p:txBody>
@@ -4928,7 +4928,7 @@
               </a:defRPr>
             </a:pPr>
             <a:r>
-              <a:t>Headline 1990–2024: no significant net alpha</a:t>
+              <a:t>The recent sample: 1990–2024</a:t>
             </a:r>
           </a:p>
         </p:txBody>
@@ -5114,7 +5114,7 @@
               </a:defRPr>
             </a:pPr>
             <a:r>
-              <a:t>Net payout: dividends and share repurchases</a:t>
+              <a:t>Dividends and share repurchases</a:t>
             </a:r>
           </a:p>
         </p:txBody>
@@ -5315,7 +5315,7 @@
               </a:defRPr>
             </a:pPr>
             <a:r>
-              <a:t>Sector positioning: allocation versus selection</a:t>
+              <a:t>Industry allocation and stock selection</a:t>
             </a:r>
           </a:p>
         </p:txBody>
@@ -5516,7 +5516,7 @@
               </a:defRPr>
             </a:pPr>
             <a:r>
-              <a:t>Signal diagnostics</a:t>
+              <a:t>Signal tests</a:t>
             </a:r>
           </a:p>
         </p:txBody>
@@ -5726,7 +5726,7 @@
               </a:defRPr>
             </a:pPr>
             <a:r>
-              <a:t>Construction: long/short and optimization</a:t>
+              <a:t>Long/short and linear optimization</a:t>
             </a:r>
           </a:p>
         </p:txBody>
@@ -5824,7 +5824,7 @@
               </a:defRPr>
             </a:pPr>
             <a:r>
-              <a:t>Unadjusted intervals, selected from a 24-run grid; 2017–2024 alphas −2.71% to 0.07% (none of the twelve 95% intervals excludes zero); return-scaled alpha is a post-spec sensitivity</a:t>
+              <a:t>Unadjusted intervals, selected from a 24-run grid; 2017–2024 alphas −2.71% to 0.07% (none of the twelve 95% intervals excludes zero); return-scaled alpha is a later sensitivity</a:t>
             </a:r>
           </a:p>
           <a:p>
@@ -5839,7 +5839,7 @@
               </a:defRPr>
             </a:pPr>
             <a:r>
-              <a:t>The next slide adds the assignment's quadratic mean-variance extension</a:t>
+              <a:t>We also test a portfolio covariance penalty</a:t>
             </a:r>
           </a:p>
         </p:txBody>
@@ -5951,7 +5951,7 @@
               </a:defRPr>
             </a:pPr>
             <a:r>
-              <a:t>Quadratic mean-variance optimization</a:t>
+              <a:t>Mean-variance portfolios</a:t>
             </a:r>
           </a:p>
         </p:txBody>
@@ -6034,7 +6034,7 @@
               </a:defRPr>
             </a:pPr>
             <a:r>
-              <a:t>Quarterly: 2% stock cap, industry bands ±5pp, turnover budget 40%; scaled costs start at 30bps</a:t>
+              <a:t>Quarterly: 2% stock cap, industry bands ±5pp, two-way turnover budget 40%; scaled costs start at 30bps</a:t>
             </a:r>
           </a:p>
           <a:p>
@@ -6064,7 +6064,7 @@
               </a:defRPr>
             </a:pPr>
             <a:r>
-              <a:t>Added during final review after observing the baseline; no unseen test or claim of optimal parameters</a:t>
+              <a:t>We chose these settings after examining the baseline; an unseen test is still needed</a:t>
             </a:r>
           </a:p>
         </p:txBody>
@@ -6412,7 +6412,7 @@
               </a:defRPr>
             </a:pPr>
             <a:r>
-              <a:t>Declared improvement: rank buffer of 150</a:t>
+              <a:t>A buffer to reduce trading</a:t>
             </a:r>
           </a:p>
         </p:txBody>
@@ -6450,7 +6450,7 @@
               </a:defRPr>
             </a:pPr>
             <a:r>
-              <a:t>Declared before any result: keep holdings ranked within the best 150; success = turnover −25% and positive net difference</a:t>
+              <a:t>Keep existing holdings while they remain in the eligible pool and within the best 150 ranks</a:t>
             </a:r>
           </a:p>
           <a:p>
@@ -6465,7 +6465,7 @@
               </a:defRPr>
             </a:pPr>
             <a:r>
-              <a:t>Verdict: succeeds</a:t>
+              <a:t>Turnover 39.8% → 28.4% a quarter (28.7% lower)</a:t>
             </a:r>
           </a:p>
           <a:p>
@@ -6480,7 +6480,7 @@
               </a:defRPr>
             </a:pPr>
             <a:r>
-              <a:t>Turnover 39.8% → 28.4% a quarter (28.7% lower)</a:t>
+              <a:t>Net-of-30 paired difference 0.34% a year [−0.10%, 0.78%]: not significant</a:t>
             </a:r>
           </a:p>
           <a:p>
@@ -6495,7 +6495,7 @@
               </a:defRPr>
             </a:pPr>
             <a:r>
-              <a:t>Net-of-30 paired difference 0.34% a year [−0.10%, 0.78%]: not significant</a:t>
+              <a:t>Gross paired difference 0.06%; the buffer changes holdings as well as costs</a:t>
             </a:r>
           </a:p>
           <a:p>
@@ -6510,22 +6510,7 @@
               </a:defRPr>
             </a:pPr>
             <a:r>
-              <a:t>Gross paired difference 0.06%; the observed difference does not prove unchanged signal quality</a:t>
-            </a:r>
-          </a:p>
-          <a:p>
-            <a:pPr>
-              <a:spcAft>
-                <a:spcPts val="600"/>
-              </a:spcAft>
-              <a:defRPr sz="1500">
-                <a:solidFill>
-                  <a:srgbClr val="1F2A33"/>
-                </a:solidFill>
-              </a:defRPr>
-            </a:pPr>
-            <a:r>
-              <a:t>2017–2024 was already seen: not a holdout</a:t>
+              <a:t>The recent period was already seen when we tested this variant</a:t>
             </a:r>
           </a:p>
         </p:txBody>
@@ -6637,7 +6622,7 @@
               </a:defRPr>
             </a:pPr>
             <a:r>
-              <a:t>Conclusion and limitations</a:t>
+              <a:t>What we conclude</a:t>
             </a:r>
           </a:p>
         </p:txBody>
@@ -6675,7 +6660,7 @@
               </a:defRPr>
             </a:pPr>
             <a:r>
-              <a:t>Replication close on return and risk; Table 2 panel B reproduced almost exactly</a:t>
+              <a:t>Return and volatility are close to the paper; turnover and some regression results differ</a:t>
             </a:r>
           </a:p>
           <a:p>
@@ -6690,7 +6675,7 @@
               </a:defRPr>
             </a:pPr>
             <a:r>
-              <a:t>The return is largely a bundle of low-volatility, momentum, profitability and investment premia</a:t>
+              <a:t>Much of the historical return is associated with known equity factors</a:t>
             </a:r>
           </a:p>
           <a:p>
@@ -6720,7 +6705,7 @@
               </a:defRPr>
             </a:pPr>
             <a:r>
-              <a:t>No evidence that the formula beats the market on recent data after known factors and costs</a:t>
+              <a:t>The recent net-alpha interval includes zero</a:t>
             </a:r>
           </a:p>
           <a:p>
@@ -6735,7 +6720,7 @@
               </a:defRPr>
             </a:pPr>
             <a:r>
-              <a:t>A cheap, transparent way to hold these premia with lower volatility than the market</a:t>
+              <a:t>Lower volatility is the most consistent feature of the portfolio</a:t>
             </a:r>
           </a:p>
           <a:p>
@@ -6838,7 +6823,7 @@
               </a:defRPr>
             </a:pPr>
             <a:r>
-              <a:t>Reproducibility</a:t>
+              <a:t>Running the project</a:t>
             </a:r>
           </a:p>
         </p:txBody>
@@ -7039,7 +7024,7 @@
               </a:defRPr>
             </a:pPr>
             <a:r>
-              <a:t>The question</a:t>
+              <a:t>What we test</a:t>
             </a:r>
           </a:p>
         </p:txBody>
@@ -7225,7 +7210,7 @@
               </a:defRPr>
             </a:pPr>
             <a:r>
-              <a:t>Data and audits</a:t>
+              <a:t>The data</a:t>
             </a:r>
           </a:p>
         </p:txBody>
@@ -7426,7 +7411,7 @@
               </a:defRPr>
             </a:pPr>
             <a:r>
-              <a:t>Baseline rule and deviations from the paper</a:t>
+              <a:t>The portfolio rule</a:t>
             </a:r>
           </a:p>
         </p:txBody>
@@ -7847,7 +7832,7 @@
               </a:defRPr>
             </a:pPr>
             <a:r>
-              <a:t>Signal construction and timing</a:t>
+              <a:t>Building the signals</a:t>
             </a:r>
           </a:p>
         </p:txBody>
@@ -8048,7 +8033,7 @@
               </a:defRPr>
             </a:pPr>
             <a:r>
-              <a:t>Replication 1929–2016: close on return and risk</a:t>
+              <a:t>Our results versus the paper</a:t>
             </a:r>
           </a:p>
         </p:txBody>
@@ -8610,7 +8595,7 @@
               </a:defRPr>
             </a:pPr>
             <a:r>
-              <a:t>Factor attribution (Table 2): largely known premia</a:t>
+              <a:t>Factor-adjusted returns</a:t>
             </a:r>
           </a:p>
         </p:txBody>
@@ -8663,7 +8648,7 @@
               </a:defRPr>
             </a:pPr>
             <a:r>
-              <a:t>1929–2016: CAPM 12.33% vs 13.9%; Carhart 7.74% vs 8.8% (gap is pre-1963)</a:t>
+              <a:t>1929–2016: CAPM 12.33% vs 13.9%; Carhart 7.74% vs 8.8% (full-sample gap remains)</a:t>
             </a:r>
           </a:p>
           <a:p>
@@ -8693,7 +8678,7 @@
               </a:defRPr>
             </a:pPr>
             <a:r>
-              <a:t>FF5 + momentum, 1963–2016: −0.11% (t −0.14) — profitability and investment explain it</a:t>
+              <a:t>FF5 + momentum, 1963–2016: −0.11% (t −0.14) — adding profitability and investment reduces alpha</a:t>
             </a:r>
           </a:p>
           <a:p>
@@ -8796,7 +8781,7 @@
               </a:defRPr>
             </a:pPr>
             <a:r>
-              <a:t>Costs (Table 4) and break-even</a:t>
+              <a:t>How costs change the result</a:t>
             </a:r>
           </a:p>
         </p:txBody>
@@ -8834,7 +8819,7 @@
               </a:defRPr>
             </a:pPr>
             <a:r>
-              <a:t>Paper cost arithmetic reproduced: turnover × 8 × cost; our turnover 38.9% vs 32%</a:t>
+              <a:t>Annual cost estimate: turnover × 8 × cost; quarterly turnover 38.9% vs 32%</a:t>
             </a:r>
           </a:p>
           <a:p>
@@ -9291,7 +9276,7 @@
               </a:defRPr>
             </a:pPr>
             <a:r>
-              <a:t>Decay: alphas fade after 1990</a:t>
+              <a:t>Results by period</a:t>
             </a:r>
           </a:p>
         </p:txBody>
@@ -9344,7 +9329,7 @@
               </a:defRPr>
             </a:pPr>
             <a:r>
-              <a:t>Significant before 1990, not after</a:t>
+              <a:t>Carhart alpha is statistically significant in the two earlier periods</a:t>
             </a:r>
           </a:p>
           <a:p>

</xml_diff>

<commit_message>
Add full slide speech scripts and rehearsal PDF
</commit_message>
<xml_diff>
--- a/Final/presentation/conservative_formula.pptx
+++ b/Final/presentation/conservative_formula.pptx
@@ -519,7 +519,25 @@
           <a:lstStyle/>
           <a:p>
             <a:r>
-              <a:t>We use monthly CRSP data to implement the paper's rule, then extend the backtest through 2024. The first comparison uses the paper's own sample. The later analysis asks whether the return survives factor adjustment and trading costs.</a:t>
+              <a:t>Hello everyone. We're Yingni Chang and Yikai Shen. Our project implements the Conservative Formula proposed by David Blitz and Pim van Vliet. The idea is to combine low volatility, momentum and shareholder payout in a portfolio of one hundred stocks.</a:t>
+            </a:r>
+          </a:p>
+          <a:p/>
+          <a:p>
+            <a:r>
+              <a:t>We first try to reproduce the US results over 1929 to 2016, which is the paper's sample. We then extend the backtest through 2024. The historical comparison is fairly close, but the recent results are weaker after costs and factor adjustment. I'll explain the rule first, then the data and results, including the payout and sector issues raised in the assignment.</a:t>
+            </a:r>
+          </a:p>
+          <a:p/>
+          <a:p>
+            <a:r>
+              <a:t>Transition: Let me start with what we wanted to test.</a:t>
+            </a:r>
+          </a:p>
+          <a:p/>
+          <a:p>
+            <a:r>
+              <a:t>Presenter cue: Introduce both authors and the purpose of the project.</a:t>
             </a:r>
           </a:p>
         </p:txBody>
@@ -589,7 +607,25 @@
           <a:lstStyle/>
           <a:p>
             <a:r>
-              <a:t>After costs, the recent alpha interval includes zero. The portfolio still has lower volatility than the market. The Conservative-minus-Speculative contrast remains different from the long-only portfolio's performance against the market.</a:t>
+              <a:t>This is our main recent comparison. After thirty-basis-point trading costs, annual Carhart alpha is 0.20 percent. The ninety-five-percent interval is roughly -1.98 percent to 2.39 percent, so it includes zero. That makes a strong claim about recent factor-adjusted outperformance difficult to support.</a:t>
+            </a:r>
+          </a:p>
+          <a:p/>
+          <a:p>
+            <a:r>
+              <a:t>The more consistent benefit is lower volatility than the market. The Conservative-minus-Speculative contrast still has a stronger result, but that includes shorting the Speculative portfolio. It is a different comparison from holding the Conservative portfolio alone, and its attribution result does not include actual borrow or financing costs.</a:t>
+            </a:r>
+          </a:p>
+          <a:p/>
+          <a:p>
+            <a:r>
+              <a:t>Transition: Next are the two implementation checks highlighted in the assignment.</a:t>
+            </a:r>
+          </a:p>
+          <a:p/>
+          <a:p>
+            <a:r>
+              <a:t>Presenter cue: Give the net-alpha estimate, interval and lower-risk result.</a:t>
             </a:r>
           </a:p>
         </p:txBody>
@@ -659,7 +695,25 @@
           <a:lstStyle/>
           <a:p>
             <a:r>
-              <a:t>This is the payout issue raised in the assignment. We compare NPY with dividends alone using otherwise identical portfolio rules. The share-count term changes both selections and returns. It measures net repurchases after issuance, rather than reported buyback cash spending.</a:t>
+              <a:t>This is one of the specific issues raised in the assignment. Dividend yield alone misses the indirect payout from repurchases. For example, with a three-percent dividend yield, ninety adjusted shares today and a one-hundred-share average, the net payout signal is thirteen percent. Issuance works in the opposite direction.</a:t>
+            </a:r>
+          </a:p>
+          <a:p/>
+          <a:p>
+            <a:r>
+              <a:t>In the matched backtest, the net-payout rule earns 14.80 percent gross annually, compared with 13.44 percent using dividends alone. We hold the other rules constant so that we are comparing the payout ranking. This shows that the share-count term matters. It is still a proxy for net repurchases after issuance, not directly observed buyback cash spending or a causal estimate of the effect of buybacks.</a:t>
+            </a:r>
+          </a:p>
+          <a:p/>
+          <a:p>
+            <a:r>
+              <a:t>Transition: The other concern is industry positioning.</a:t>
+            </a:r>
+          </a:p>
+          <a:p/>
+          <a:p>
+            <a:r>
+              <a:t>Presenter cue: Emphasize the assignment's payout warning and the matched comparison.</a:t>
             </a:r>
           </a:p>
         </p:txBody>
@@ -729,7 +783,31 @@
           <a:lstStyle/>
           <a:p>
             <a:r>
-              <a:t>We compare with the same formation universe so that industry allocation is not confused with a broad-market universe difference. The attribution includes the selection interaction. We then apply the course's count-proportional quotas, which change the paper's global screen.</a:t>
+              <a:t>For sector positioning, we use Fama-French twelve industries. We compare our portfolio with a cap-weighted reference from the same formation universe, so a broad-market universe difference does not get mistaken for industry allocation.</a:t>
+            </a:r>
+          </a:p>
+          <a:p/>
+          <a:p>
+            <a:r>
+              <a:t>Over the paper sample, industry allocation contributes about 0.82 percent a year and stock selection about 3.80 percent. A separate universe-to-market term completes the monthly identity. These are arithmetic contributions, not contributions to CAGR.</a:t>
+            </a:r>
+          </a:p>
+          <a:p/>
+          <a:p>
+            <a:r>
+              <a:t>We also follow the course's quota idea: if an industry contains fifteen percent of universe stocks, it receives about fifteen of the one hundred holdings. That variant earns 14.51 percent gross annually. It changes the paper's global screen and was considered after the baseline results, so we treat it as an exploratory comparison.</a:t>
+            </a:r>
+          </a:p>
+          <a:p/>
+          <a:p>
+            <a:r>
+              <a:t>Transition: We also test the signals outside the original stock-selection rule.</a:t>
+            </a:r>
+          </a:p>
+          <a:p/>
+          <a:p>
+            <a:r>
+              <a:t>Presenter cue: Explain the reference universe and then the industry quota rule.</a:t>
             </a:r>
           </a:p>
         </p:txBody>
@@ -799,7 +877,25 @@
           <a:lstStyle/>
           <a:p>
             <a:r>
-              <a:t>These tests use industry-neutral exposures and industry-adjusted returns. Rank IC and a mean decile spread can tell different stories when returns are skewed. The factor-mimicking portfolios are gross diagnostic portfolios and may have substantial leverage.</a:t>
+              <a:t>We next examine the signals separately. We remove industry means, standardize the exposures and clip extremes. The information coefficient, or IC, is the rank correlation between a signal and later industry-adjusted returns.</a:t>
+            </a:r>
+          </a:p>
+          <a:p/>
+          <a:p>
+            <a:r>
+              <a:t>The composite's one-month IC is about 0.047. We also look at deciles, persistence and longer holding horizons. A positive rank correlation does not always imply a strong mean spread when returns are skewed. The factor-mimicking portfolios help separate signal exposures from industry, size and historical Fama-French controls. Their gross information ratio falls as we average more old portfolios, along with turnover. They are diagnostic portfolios with leverage, rather than a fully costed trading strategy.</a:t>
+            </a:r>
+          </a:p>
+          <a:p/>
+          <a:p>
+            <a:r>
+              <a:t>Transition: That leads to the trading and portfolio-construction experiments.</a:t>
+            </a:r>
+          </a:p>
+          <a:p/>
+          <a:p>
+            <a:r>
+              <a:t>Presenter cue: Define IC and explain why rank correlation differs from a mean return spread.</a:t>
             </a:r>
           </a:p>
         </p:txBody>
@@ -869,7 +965,25 @@
           <a:lstStyle/>
           <a:p>
             <a:r>
-              <a:t>The initial buy-and-hold long/short loses all capital in the early data. Monthly reweighting was considered after seeing that outcome, and still gives severe drawdowns. The linear optimizer results also need caution: the displayed intervals are unadjusted for testing several settings.</a:t>
+              <a:t>The long/short exercise buys the top composite decile and sells the bottom decile. We compare holding periods, trading costs and monthly borrow fees. The original buy-and-hold cohorts lose all capital in the early data for several holding periods. We then examine monthly reweighting, which still has an extremely deep drawdown. That alternative was chosen after seeing the losses.</a:t>
+            </a:r>
+          </a:p>
+          <a:p/>
+          <a:p>
+            <a:r>
+              <a:t>The linear optimizer gives stronger-looking recent results for some settings. It caps individual stocks, constrains industries and limits turnover. But two of the four 95% intervals exclude zero for the four displayed recent examples, and those intervals are unadjusted for testing many settings. The post-2016 estimates are weaker. We would need an unseen test before treating the best grid result as reliable.</a:t>
+            </a:r>
+          </a:p>
+          <a:p/>
+          <a:p>
+            <a:r>
+              <a:t>Transition: The next model adds a covariance penalty.</a:t>
+            </a:r>
+          </a:p>
+          <a:p/>
+          <a:p>
+            <a:r>
+              <a:t>Presenter cue: Separate the failed trading experiment from the optimizer grid.</a:t>
             </a:r>
           </a:p>
         </p:txBody>
@@ -939,7 +1053,25 @@
           <a:lstStyle/>
           <a:p>
             <a:r>
-              <a:t>With only 36 observations for about 1,000 stocks, sample covariance needs regularization. We use half sample covariance and half diagonal covariance. More risk aversion lowers realized volatility, but these long-only portfolios remain highly correlated with the market. We chose these settings after examining the baseline.</a:t>
+              <a:t>The quadratic model adds portfolio variance to the objective, alongside expected return and trading cost. We estimate covariance using the last thirty-six monthly returns. With about one thousand stocks and only thirty-six observations, sample covariance needs regularization, so we combine it equally with diagonal covariance.</a:t>
+            </a:r>
+          </a:p>
+          <a:p/>
+          <a:p>
+            <a:r>
+              <a:t>For 1990 to 2024, risk aversion five gives net CAGR of 11.59 percent and volatility of 12.51 percent. At risk aversion twenty, those figures are 10.39 percent and 11.51 percent. More risk aversion lowers realized volatility, but market correlations remain high. These long-only portfolios are not market-neutral. We chose these settings after examining the baseline and have not established that they are optimal.</a:t>
+            </a:r>
+          </a:p>
+          <a:p/>
+          <a:p>
+            <a:r>
+              <a:t>Transition: Finally, we test a simpler change aimed at reducing turnover.</a:t>
+            </a:r>
+          </a:p>
+          <a:p/>
+          <a:p>
+            <a:r>
+              <a:t>Presenter cue: Use the table to compare the two risk-aversion settings.</a:t>
             </a:r>
           </a:p>
         </p:txBody>
@@ -1009,7 +1141,25 @@
           <a:lstStyle/>
           <a:p>
             <a:r>
-              <a:t>We fixed the 150-rank buffer before testing it. It reduces turnover, and its net point estimate is positive, but the paired interval includes zero. Since it also changes holdings, we cannot attribute the entire difference to cost savings.</a:t>
+              <a:t>The buffer asks whether we need to sell a holding immediately when its rank slips below one hundred. We keep it while it remains eligible and among the best one hundred and fifty ranks, then fill vacancies. We fixed that buffer size before testing the variant.</a:t>
+            </a:r>
+          </a:p>
+          <a:p/>
+          <a:p>
+            <a:r>
+              <a:t>Quarterly turnover falls from 39.8 percent to 28.4 percent. The net paired difference is 0.34 percent a year, but its interval includes zero. The modification reduces trading, while also changing holdings, so we cannot attribute the whole return difference to costs. We view it as a useful trading experiment, not proof of a better signal.</a:t>
+            </a:r>
+          </a:p>
+          <a:p/>
+          <a:p>
+            <a:r>
+              <a:t>Transition: These comparisons lead us to the main conclusion.</a:t>
+            </a:r>
+          </a:p>
+          <a:p/>
+          <a:p>
+            <a:r>
+              <a:t>Presenter cue: Point to the turnover reduction and the confidence interval.</a:t>
             </a:r>
           </a:p>
         </p:txBody>
@@ -1079,7 +1229,25 @@
           <a:lstStyle/>
           <a:p>
             <a:r>
-              <a:t>We reproduce much of the historical return-and-risk pattern. The remaining turnover and regression gaps prevent an exact replication claim. For recent data, lower volatility is more consistent than positive net alpha. The extra strategies need an unseen test before stronger claims would be justified.</a:t>
+              <a:t>Our implementation reproduces much of the paper's historical return and risk pattern, but it is not an exact replication. Turnover and some regression results still differ. We have also checked the two issues highlighted in the assignment: net payout includes the adjusted share-count term, and industry positioning is measured and tested separately.</a:t>
+            </a:r>
+          </a:p>
+          <a:p/>
+          <a:p>
+            <a:r>
+              <a:t>For recent data, lower volatility is more consistent than positive net alpha. The buffer and optimizers change trading and risk, but their results do not yet show a stronger strategy on unseen data. Our conclusion is that this is a useful, understandable factor portfolio, with important limits to a claim of persistent outperformance.</a:t>
+            </a:r>
+          </a:p>
+          <a:p/>
+          <a:p>
+            <a:r>
+              <a:t>Transition: I'll finish with the code and data needed to rerun the project.</a:t>
+            </a:r>
+          </a:p>
+          <a:p/>
+          <a:p>
+            <a:r>
+              <a:t>Presenter cue: Pause on the main conclusion and the unresolved turnover difference.</a:t>
             </a:r>
           </a:p>
         </p:txBody>
@@ -1149,7 +1317,19 @@
           <a:lstStyle/>
           <a:p>
             <a:r>
-              <a:t>The notebook and both PDFs read saved aggregate results. The full calculation starts with the private CRSP inputs and runs through research.run_all. Source data, cleaning audits and run instructions are included in the private submission package.</a:t>
+              <a:t>The main calculation command is python, dash m, research dot run all, from the Final folder. The notebook and PDFs read the saved aggregate results, so they can be opened without the licensed stock-level data. A full rebuild uses the private CRSP inputs and the cleaning code first.</a:t>
+            </a:r>
+          </a:p>
+          <a:p/>
+          <a:p>
+            <a:r>
+              <a:t>We include the source, notebook, reports, data audits and run instructions in the course package. The public repository contains code and aggregate results; the licensed data stay in the private submission. This allows the calculations to be checked without putting the raw observations on GitHub. Thank you. We're happy to take questions.</a:t>
+            </a:r>
+          </a:p>
+          <a:p/>
+          <a:p>
+            <a:r>
+              <a:t>Presenter cue: Give the entry point; finish without reading every command.</a:t>
             </a:r>
           </a:p>
         </p:txBody>
@@ -1219,7 +1399,25 @@
           <a:lstStyle/>
           <a:p>
             <a:r>
-              <a:t>We compare the published return and risk first. Then we examine known factors, changes across periods and trading costs. These comparisons were fixed before computing the post-2016 portfolio returns. The additional variants are separate experiments.</a:t>
+              <a:t>We organize the analysis around three comparisons. First, can we reproduce the paper's return, volatility and turnover? Second, how much of the return is explained by familiar equity factors? Third, what happens when we move to recent periods and include trading costs?</a:t>
+            </a:r>
+          </a:p>
+          <a:p/>
+          <a:p>
+            <a:r>
+              <a:t>These questions matter because a strong result over almost ninety years does not necessarily mean that the strategy still has a useful advantage today. We use the Carhart model as our main factor adjustment and compare gross returns with returns at ten and thirty basis points per dollar traded. The fixed comparison periods were chosen before computing the post-2016 portfolio results.</a:t>
+            </a:r>
+          </a:p>
+          <a:p/>
+          <a:p>
+            <a:r>
+              <a:t>Transition: Those comparisons depend on the data, so I'll turn to the CRSP inputs.</a:t>
+            </a:r>
+          </a:p>
+          <a:p/>
+          <a:p>
+            <a:r>
+              <a:t>Presenter cue: Explain the distinction between replication and recent performance.</a:t>
             </a:r>
           </a:p>
         </p:txBody>
@@ -1289,7 +1487,25 @@
           <a:lstStyle/>
           <a:p>
             <a:r>
-              <a:t>The data work matters here. We retain delisted stocks, use historical company and exchange information, and separate missing signal inputs from returns on already-held positions. The early universe is much smaller than 1,000 names.</a:t>
+              <a:t>We use the full monthly CRSP files from WRDS. After cleaning, the panel has about 3.95 million security-month observations and 26,746 securities. We combine stock returns with historical company information, delistings, distributions and the market index. We also use Fama-French factors.</a:t>
+            </a:r>
+          </a:p>
+          <a:p/>
+          <a:p>
+            <a:r>
+              <a:t>Two choices are especially important. We keep stocks that disappear, including their terminal returns, instead of looking only at survivors. We also use one common share class per company to avoid double counting. The earliest portfolio universe has only 393 eligible stocks. It first reaches one thousand in June 1964, so the early backtest necessarily uses a smaller universe.</a:t>
+            </a:r>
+          </a:p>
+          <a:p/>
+          <a:p>
+            <a:r>
+              <a:t>Transition: With those files cleaned, the selection rule is fairly simple.</a:t>
+            </a:r>
+          </a:p>
+          <a:p/>
+          <a:p>
+            <a:r>
+              <a:t>Presenter cue: Point to the coverage counts, then emphasize delistings and the early universe.</a:t>
             </a:r>
           </a:p>
         </p:txBody>
@@ -1359,7 +1575,25 @@
           <a:lstStyle/>
           <a:p>
             <a:r>
-              <a:t>We require 36 months of return history before the size cut. After that, we use the low-volatility half and combine momentum and payout ranks. The largest share class represents each company. We document the choices that the paper leaves open.</a:t>
+              <a:t>At each quarter-end, we first require thirty-six consecutive months of return history. We then select the largest one thousand eligible stocks by market capitalization. From this group, we keep the half with the lowest historical volatility.</a:t>
+            </a:r>
+          </a:p>
+          <a:p/>
+          <a:p>
+            <a:r>
+              <a:t>Within that lower-volatility pool, we rank momentum and net payout favorably, average the two ranks, and select the best one hundred stocks. Each receives an equal weight. The holdings then drift with returns for the next three months. We rebalance using information available at the previous quarter-end. Applying the history requirement before the size cut is important because reversing that order changes the universe.</a:t>
+            </a:r>
+          </a:p>
+          <a:p/>
+          <a:p>
+            <a:r>
+              <a:t>Transition: I'll show how we calculate the three inputs to those ranks.</a:t>
+            </a:r>
+          </a:p>
+          <a:p/>
+          <a:p>
+            <a:r>
+              <a:t>Presenter cue: Follow the selection order on the slide.</a:t>
             </a:r>
           </a:p>
         </p:txBody>
@@ -1429,7 +1663,25 @@
           <a:lstStyle/>
           <a:p>
             <a:r>
-              <a:t>Momentum uses price returns and excludes the latest month. Portfolio returns include distributions. For payout, both prices and shares need split adjustment: a split should not appear as a repurchase. The 12-month dividend window is our disclosed convention.</a:t>
+              <a:t>Volatility is the standard deviation of thirty-six monthly total returns, expressed in annual units. Momentum compounds eleven monthly price returns and skips the most recent month. Portfolio performance, in contrast, uses total returns including distributions and delistings.</a:t>
+            </a:r>
+          </a:p>
+          <a:p/>
+          <a:p>
+            <a:r>
+              <a:t>Net payout combines dividend yield with the change in adjusted shares. We use the latest share count relative to its twenty-four-month average. Repurchases increase the signal, while issuance decreases it. Both prices and shares are split-adjusted, so a stock split should not create an artificial buyback. The twelve-month dividend window is a disclosed choice because the paper does not fully specify that part.</a:t>
+            </a:r>
+          </a:p>
+          <a:p/>
+          <a:p>
+            <a:r>
+              <a:t>Transition: Now we can compare the backtest with the published figures.</a:t>
+            </a:r>
+          </a:p>
+          <a:p/>
+          <a:p>
+            <a:r>
+              <a:t>Presenter cue: Explain each signal briefly; spend most of the time on payout.</a:t>
             </a:r>
           </a:p>
         </p:txBody>
@@ -1499,7 +1751,25 @@
           <a:lstStyle/>
           <a:p>
             <a:r>
-              <a:t>The main return and volatility figures are close. The turnover difference is larger and remains unresolved. We have not changed the rule to force agreement. Share classes, the size measure and payout estimation may affect the result, but we cannot separate their effects.</a:t>
+              <a:t>Over the paper's sample, our Conservative portfolio compounds at 14.80 percent a year before costs, compared with 15.10 percent in the paper. Our volatility is 17.06 percent, compared with 16.50 percent. The broad return-and-risk result is therefore close.</a:t>
+            </a:r>
+          </a:p>
+          <a:p/>
+          <a:p>
+            <a:r>
+              <a:t>The main unresolved difference is quarterly turnover: we get 38.9 percent, compared with 32.0 percent. Some control and regression results differ as well. Share-class choices, capitalization and dividend estimation could contribute, but we cannot separate their effects. We leave these gaps visible rather than adjusting the strategy to force a match.</a:t>
+            </a:r>
+          </a:p>
+          <a:p/>
+          <a:p>
+            <a:r>
+              <a:t>Transition: Close raw returns are only part of the comparison; let's look at factor-adjusted returns.</a:t>
+            </a:r>
+          </a:p>
+          <a:p/>
+          <a:p>
+            <a:r>
+              <a:t>Presenter cue: Point to the return/risk comparison and the growth chart.</a:t>
             </a:r>
           </a:p>
         </p:txBody>
@@ -1569,7 +1839,25 @@
           <a:lstStyle/>
           <a:p>
             <a:r>
-              <a:t>The factor model changes the interpretation of the historical return. Adding profitability and investment reduces estimated alpha substantially. The post-1963 comparisons are closer than the full-sample ones; a different sample should not be mistaken for evidence of the cause of the gap.</a:t>
+              <a:t>Alpha here is the return left after accounting for the factors in the regression. A high raw return can still have little alpha if the portfolio mainly holds known factor exposures.</a:t>
+            </a:r>
+          </a:p>
+          <a:p/>
+          <a:p>
+            <a:r>
+              <a:t>For the Conservative long-only portfolio, annual Carhart alpha over the paper sample is 3.23 percent. When we use the five Fama-French factors plus momentum over 1963 to 2016, the estimate falls to -0.11 percent. Adding profitability and investment changes the interpretation substantially. We also compare the Conservative-minus-Speculative contrast with the paper. The post-1963 comparisons are closer than the full-sample ones, but that does not establish the cause of the remaining difference.</a:t>
+            </a:r>
+          </a:p>
+          <a:p/>
+          <a:p>
+            <a:r>
+              <a:t>Transition: Trading costs are another reason gross return can be misleading.</a:t>
+            </a:r>
+          </a:p>
+          <a:p/>
+          <a:p>
+            <a:r>
+              <a:t>Presenter cue: Define alpha before discussing the factor models.</a:t>
             </a:r>
           </a:p>
         </p:txBody>
@@ -1639,7 +1927,25 @@
           <a:lstStyle/>
           <a:p>
             <a:r>
-              <a:t>We charge both purchases and sales. Break-even is the cost per dollar traded at which market excess return or Carhart alpha reaches zero. Flat cost scenarios do not capture historical changes in liquidity or market impact.</a:t>
+              <a:t>We charge costs on both purchases and sales. Thirty basis points means a charge of zero point three percent per dollar traded. Quarterly turnover on the slide is single-counted, so a purchase and sale are not counted twice in that measure.</a:t>
+            </a:r>
+          </a:p>
+          <a:p/>
+          <a:p>
+            <a:r>
+              <a:t>At thirty basis points, the paper-period annual compound return falls to 13.73 percent. For 1990 to 2024, the break-even cost for Carhart alpha is approximately 36 basis points. Break-even means the cost at which the estimated advantage reaches zero. In the period after 2016, gross excess return and alpha are already nonpositive. These are flat cost scenarios, not a complete model of historical liquidity or market impact.</a:t>
+            </a:r>
+          </a:p>
+          <a:p/>
+          <a:p>
+            <a:r>
+              <a:t>Transition: Let's look at how the estimates change across periods.</a:t>
+            </a:r>
+          </a:p>
+          <a:p/>
+          <a:p>
+            <a:r>
+              <a:t>Presenter cue: Explain basis points and the single-counted turnover convention.</a:t>
             </a:r>
           </a:p>
         </p:txBody>
@@ -1709,7 +2015,25 @@
           <a:lstStyle/>
           <a:p>
             <a:r>
-              <a:t>The earlier estimates are stronger than the recent ones. The sample after 2016 is only eight years, so its interval is wide. We do not interpret an insignificant estimate as proof that expected alpha is exactly zero.</a:t>
+              <a:t>The subperiods show why the long history needs to be broken up. The earlier Carhart estimates are stronger, while the recent estimates are weaker. The rolling plots show a similar pattern, although adjacent windows overlap and should not be treated as independent observations.</a:t>
+            </a:r>
+          </a:p>
+          <a:p/>
+          <a:p>
+            <a:r>
+              <a:t>For 2017 to 2024, gross Carhart alpha is -1.21 percent. Its ninety-five-percent interval runs from -5.12 percent to 2.69 percent. That interval is wide because the sample contains only eight years. We do not find strong evidence of outperformance in that period, but an insignificant estimate is not proof that expected alpha is exactly zero.</a:t>
+            </a:r>
+          </a:p>
+          <a:p/>
+          <a:p>
+            <a:r>
+              <a:t>Transition: We will now focus on the recent sample in more detail.</a:t>
+            </a:r>
+          </a:p>
+          <a:p/>
+          <a:p>
+            <a:r>
+              <a:t>Presenter cue: Trace the early-to-recent pattern; do not read every table cell.</a:t>
             </a:r>
           </a:p>
         </p:txBody>

</xml_diff>